<commit_message>
PSR queue: booking flow completes inline — auto-close after confirm, context-aware Log Call button
</commit_message>
<xml_diff>
--- a/Everlywell_Platform_Slides_V3.1.pptx
+++ b/Everlywell_Platform_Slides_V3.1.pptx
@@ -11,6 +11,7 @@
     <p:sldId id="258" r:id="rId2"/>
     <p:sldId id="257" r:id="rId3"/>
     <p:sldId id="259" r:id="rId9"/>
+    <p:sldId id="260" r:id="rId10"/>
   </p:sldIdLst>
   <p:sldSz cx="18288000" cy="10287000"/>
   <p:notesSz cx="10287000" cy="18288000"/>
@@ -15414,6 +15415,3297 @@
                 <a:latin typeface="Calibri"/>
               </a:rPr>
               <a:t>5 Slack channels eliminated as operational hubs    |   3 workflows fully automated by platform intelligence   |   2 workflows eliminated by architecture   |   1 unified Care Team Queue — SLA-tracked, audited, zero manual monitoring</a:t>
+            </a:r>
+          </a:p>
+        </p:txBody>
+      </p:sp>
+    </p:spTree>
+  </p:cSld>
+  <p:clrMapOvr>
+    <a:masterClrMapping/>
+  </p:clrMapOvr>
+</p:sld>
+</file>
+
+<file path=ppt/slides/slide4.xml><?xml version="1.0" encoding="utf-8"?>
+<p:sld xmlns:a="http://schemas.openxmlformats.org/drawingml/2006/main" xmlns:p="http://schemas.openxmlformats.org/presentationml/2006/main" xmlns:r="http://schemas.openxmlformats.org/officeDocument/2006/relationships">
+  <p:cSld>
+    <p:spTree>
+      <p:nvGrpSpPr>
+        <p:cNvPr id="1" name=""/>
+        <p:cNvGrpSpPr/>
+        <p:nvPr/>
+      </p:nvGrpSpPr>
+      <p:grpSpPr/>
+      <p:sp>
+        <p:nvSpPr>
+          <p:cNvPr id="2" name="Rectangle 1"/>
+          <p:cNvSpPr/>
+          <p:nvPr/>
+        </p:nvSpPr>
+        <p:spPr>
+          <a:xfrm>
+            <a:off x="0" y="0"/>
+            <a:ext cx="18288000" cy="10287000"/>
+          </a:xfrm>
+          <a:prstGeom prst="rect">
+            <a:avLst/>
+          </a:prstGeom>
+          <a:solidFill>
+            <a:srgbClr val="0A1628"/>
+          </a:solidFill>
+          <a:ln>
+            <a:noFill/>
+          </a:ln>
+        </p:spPr>
+        <p:style>
+          <a:lnRef idx="1">
+            <a:schemeClr val="accent1"/>
+          </a:lnRef>
+          <a:fillRef idx="3">
+            <a:schemeClr val="accent1"/>
+          </a:fillRef>
+          <a:effectRef idx="2">
+            <a:schemeClr val="accent1"/>
+          </a:effectRef>
+          <a:fontRef idx="minor">
+            <a:schemeClr val="lt1"/>
+          </a:fontRef>
+        </p:style>
+        <p:txBody>
+          <a:bodyPr rtlCol="0" anchor="ctr"/>
+          <a:lstStyle/>
+          <a:p>
+            <a:pPr algn="ctr"/>
+          </a:p>
+        </p:txBody>
+      </p:sp>
+      <p:sp>
+        <p:nvSpPr>
+          <p:cNvPr id="3" name="Oval 2"/>
+          <p:cNvSpPr/>
+          <p:nvPr/>
+        </p:nvSpPr>
+        <p:spPr>
+          <a:xfrm>
+            <a:off x="7543800" y="4137660"/>
+            <a:ext cx="3200400" cy="2011680"/>
+          </a:xfrm>
+          <a:prstGeom prst="ellipse">
+            <a:avLst/>
+          </a:prstGeom>
+          <a:noFill/>
+          <a:ln w="6350">
+            <a:solidFill>
+              <a:srgbClr val="162B4A"/>
+            </a:solidFill>
+          </a:ln>
+        </p:spPr>
+        <p:style>
+          <a:lnRef idx="1">
+            <a:schemeClr val="accent1"/>
+          </a:lnRef>
+          <a:fillRef idx="3">
+            <a:schemeClr val="accent1"/>
+          </a:fillRef>
+          <a:effectRef idx="2">
+            <a:schemeClr val="accent1"/>
+          </a:effectRef>
+          <a:fontRef idx="minor">
+            <a:schemeClr val="lt1"/>
+          </a:fontRef>
+        </p:style>
+        <p:txBody>
+          <a:bodyPr rtlCol="0" anchor="ctr"/>
+          <a:lstStyle/>
+          <a:p>
+            <a:pPr algn="ctr"/>
+          </a:p>
+        </p:txBody>
+      </p:sp>
+      <p:sp>
+        <p:nvSpPr>
+          <p:cNvPr id="4" name="Oval 3"/>
+          <p:cNvSpPr/>
+          <p:nvPr/>
+        </p:nvSpPr>
+        <p:spPr>
+          <a:xfrm>
+            <a:off x="6172200" y="3223260"/>
+            <a:ext cx="5943600" cy="3840480"/>
+          </a:xfrm>
+          <a:prstGeom prst="ellipse">
+            <a:avLst/>
+          </a:prstGeom>
+          <a:noFill/>
+          <a:ln w="6350">
+            <a:solidFill>
+              <a:srgbClr val="162B4A"/>
+            </a:solidFill>
+          </a:ln>
+        </p:spPr>
+        <p:style>
+          <a:lnRef idx="1">
+            <a:schemeClr val="accent1"/>
+          </a:lnRef>
+          <a:fillRef idx="3">
+            <a:schemeClr val="accent1"/>
+          </a:fillRef>
+          <a:effectRef idx="2">
+            <a:schemeClr val="accent1"/>
+          </a:effectRef>
+          <a:fontRef idx="minor">
+            <a:schemeClr val="lt1"/>
+          </a:fontRef>
+        </p:style>
+        <p:txBody>
+          <a:bodyPr rtlCol="0" anchor="ctr"/>
+          <a:lstStyle/>
+          <a:p>
+            <a:pPr algn="ctr"/>
+          </a:p>
+        </p:txBody>
+      </p:sp>
+      <p:sp>
+        <p:nvSpPr>
+          <p:cNvPr id="5" name="Oval 4"/>
+          <p:cNvSpPr/>
+          <p:nvPr/>
+        </p:nvSpPr>
+        <p:spPr>
+          <a:xfrm>
+            <a:off x="4572000" y="2171700"/>
+            <a:ext cx="9144000" cy="5943600"/>
+          </a:xfrm>
+          <a:prstGeom prst="ellipse">
+            <a:avLst/>
+          </a:prstGeom>
+          <a:noFill/>
+          <a:ln w="5080">
+            <a:solidFill>
+              <a:srgbClr val="162B4A"/>
+            </a:solidFill>
+          </a:ln>
+        </p:spPr>
+        <p:style>
+          <a:lnRef idx="1">
+            <a:schemeClr val="accent1"/>
+          </a:lnRef>
+          <a:fillRef idx="3">
+            <a:schemeClr val="accent1"/>
+          </a:fillRef>
+          <a:effectRef idx="2">
+            <a:schemeClr val="accent1"/>
+          </a:effectRef>
+          <a:fontRef idx="minor">
+            <a:schemeClr val="lt1"/>
+          </a:fontRef>
+        </p:style>
+        <p:txBody>
+          <a:bodyPr rtlCol="0" anchor="ctr"/>
+          <a:lstStyle/>
+          <a:p>
+            <a:pPr algn="ctr"/>
+          </a:p>
+        </p:txBody>
+      </p:sp>
+      <p:sp>
+        <p:nvSpPr>
+          <p:cNvPr id="6" name="Oval 5"/>
+          <p:cNvSpPr/>
+          <p:nvPr/>
+        </p:nvSpPr>
+        <p:spPr>
+          <a:xfrm>
+            <a:off x="2743200" y="1028700"/>
+            <a:ext cx="12801600" cy="8229600"/>
+          </a:xfrm>
+          <a:prstGeom prst="ellipse">
+            <a:avLst/>
+          </a:prstGeom>
+          <a:noFill/>
+          <a:ln w="5080">
+            <a:solidFill>
+              <a:srgbClr val="0F2035"/>
+            </a:solidFill>
+          </a:ln>
+        </p:spPr>
+        <p:style>
+          <a:lnRef idx="1">
+            <a:schemeClr val="accent1"/>
+          </a:lnRef>
+          <a:fillRef idx="3">
+            <a:schemeClr val="accent1"/>
+          </a:fillRef>
+          <a:effectRef idx="2">
+            <a:schemeClr val="accent1"/>
+          </a:effectRef>
+          <a:fontRef idx="minor">
+            <a:schemeClr val="lt1"/>
+          </a:fontRef>
+        </p:style>
+        <p:txBody>
+          <a:bodyPr rtlCol="0" anchor="ctr"/>
+          <a:lstStyle/>
+          <a:p>
+            <a:pPr algn="ctr"/>
+          </a:p>
+        </p:txBody>
+      </p:sp>
+      <p:cxnSp>
+        <p:nvCxnSpPr>
+          <p:cNvPr id="7" name="Connector 6"/>
+          <p:cNvCxnSpPr/>
+          <p:nvPr/>
+        </p:nvCxnSpPr>
+        <p:spPr>
+          <a:xfrm>
+            <a:off x="0" y="5143500"/>
+            <a:ext cx="18288000" cy="0"/>
+          </a:xfrm>
+          <a:prstGeom prst="line">
+            <a:avLst/>
+          </a:prstGeom>
+          <a:ln w="5080">
+            <a:solidFill>
+              <a:srgbClr val="1A3050"/>
+            </a:solidFill>
+            <a:prstDash val="solid"/>
+          </a:ln>
+        </p:spPr>
+        <p:style>
+          <a:lnRef idx="2">
+            <a:schemeClr val="accent1"/>
+          </a:lnRef>
+          <a:fillRef idx="0">
+            <a:schemeClr val="accent1"/>
+          </a:fillRef>
+          <a:effectRef idx="1">
+            <a:schemeClr val="accent1"/>
+          </a:effectRef>
+          <a:fontRef idx="minor">
+            <a:schemeClr val="tx1"/>
+          </a:fontRef>
+        </p:style>
+      </p:cxnSp>
+      <p:cxnSp>
+        <p:nvCxnSpPr>
+          <p:cNvPr id="8" name="Connector 7"/>
+          <p:cNvCxnSpPr/>
+          <p:nvPr/>
+        </p:nvCxnSpPr>
+        <p:spPr>
+          <a:xfrm>
+            <a:off x="9144000" y="0"/>
+            <a:ext cx="0" cy="10287000"/>
+          </a:xfrm>
+          <a:prstGeom prst="line">
+            <a:avLst/>
+          </a:prstGeom>
+          <a:ln w="5080">
+            <a:solidFill>
+              <a:srgbClr val="1A3050"/>
+            </a:solidFill>
+            <a:prstDash val="solid"/>
+          </a:ln>
+        </p:spPr>
+        <p:style>
+          <a:lnRef idx="2">
+            <a:schemeClr val="accent1"/>
+          </a:lnRef>
+          <a:fillRef idx="0">
+            <a:schemeClr val="accent1"/>
+          </a:fillRef>
+          <a:effectRef idx="1">
+            <a:schemeClr val="accent1"/>
+          </a:effectRef>
+          <a:fontRef idx="minor">
+            <a:schemeClr val="tx1"/>
+          </a:fontRef>
+        </p:style>
+      </p:cxnSp>
+      <p:cxnSp>
+        <p:nvCxnSpPr>
+          <p:cNvPr id="9" name="Connector 8"/>
+          <p:cNvCxnSpPr/>
+          <p:nvPr/>
+        </p:nvCxnSpPr>
+        <p:spPr>
+          <a:xfrm flipH="1" flipV="1">
+            <a:off x="2148840" y="2286000"/>
+            <a:ext cx="6995160" cy="2857500"/>
+          </a:xfrm>
+          <a:prstGeom prst="line">
+            <a:avLst/>
+          </a:prstGeom>
+          <a:ln w="19050">
+            <a:solidFill>
+              <a:srgbClr val="7C3AED"/>
+            </a:solidFill>
+            <a:prstDash val="sysDash"/>
+          </a:ln>
+        </p:spPr>
+        <p:style>
+          <a:lnRef idx="2">
+            <a:schemeClr val="accent1"/>
+          </a:lnRef>
+          <a:fillRef idx="0">
+            <a:schemeClr val="accent1"/>
+          </a:fillRef>
+          <a:effectRef idx="1">
+            <a:schemeClr val="accent1"/>
+          </a:effectRef>
+          <a:fontRef idx="minor">
+            <a:schemeClr val="tx1"/>
+          </a:fontRef>
+        </p:style>
+      </p:cxnSp>
+      <p:cxnSp>
+        <p:nvCxnSpPr>
+          <p:cNvPr id="10" name="Connector 9"/>
+          <p:cNvCxnSpPr/>
+          <p:nvPr/>
+        </p:nvCxnSpPr>
+        <p:spPr>
+          <a:xfrm flipV="1">
+            <a:off x="9144000" y="2286000"/>
+            <a:ext cx="6995159" cy="2857500"/>
+          </a:xfrm>
+          <a:prstGeom prst="line">
+            <a:avLst/>
+          </a:prstGeom>
+          <a:ln w="19050">
+            <a:solidFill>
+              <a:srgbClr val="0891B2"/>
+            </a:solidFill>
+            <a:prstDash val="sysDash"/>
+          </a:ln>
+        </p:spPr>
+        <p:style>
+          <a:lnRef idx="2">
+            <a:schemeClr val="accent1"/>
+          </a:lnRef>
+          <a:fillRef idx="0">
+            <a:schemeClr val="accent1"/>
+          </a:fillRef>
+          <a:effectRef idx="1">
+            <a:schemeClr val="accent1"/>
+          </a:effectRef>
+          <a:fontRef idx="minor">
+            <a:schemeClr val="tx1"/>
+          </a:fontRef>
+        </p:style>
+      </p:cxnSp>
+      <p:cxnSp>
+        <p:nvCxnSpPr>
+          <p:cNvPr id="11" name="Connector 10"/>
+          <p:cNvCxnSpPr/>
+          <p:nvPr/>
+        </p:nvCxnSpPr>
+        <p:spPr>
+          <a:xfrm flipH="1">
+            <a:off x="2148840" y="5143500"/>
+            <a:ext cx="6995160" cy="2857500"/>
+          </a:xfrm>
+          <a:prstGeom prst="line">
+            <a:avLst/>
+          </a:prstGeom>
+          <a:ln w="19050">
+            <a:solidFill>
+              <a:srgbClr val="D97706"/>
+            </a:solidFill>
+            <a:prstDash val="sysDash"/>
+          </a:ln>
+        </p:spPr>
+        <p:style>
+          <a:lnRef idx="2">
+            <a:schemeClr val="accent1"/>
+          </a:lnRef>
+          <a:fillRef idx="0">
+            <a:schemeClr val="accent1"/>
+          </a:fillRef>
+          <a:effectRef idx="1">
+            <a:schemeClr val="accent1"/>
+          </a:effectRef>
+          <a:fontRef idx="minor">
+            <a:schemeClr val="tx1"/>
+          </a:fontRef>
+        </p:style>
+      </p:cxnSp>
+      <p:cxnSp>
+        <p:nvCxnSpPr>
+          <p:cNvPr id="12" name="Connector 11"/>
+          <p:cNvCxnSpPr/>
+          <p:nvPr/>
+        </p:nvCxnSpPr>
+        <p:spPr>
+          <a:xfrm>
+            <a:off x="9144000" y="5143500"/>
+            <a:ext cx="6995159" cy="2857500"/>
+          </a:xfrm>
+          <a:prstGeom prst="line">
+            <a:avLst/>
+          </a:prstGeom>
+          <a:ln w="19050">
+            <a:solidFill>
+              <a:srgbClr val="059669"/>
+            </a:solidFill>
+            <a:prstDash val="sysDash"/>
+          </a:ln>
+        </p:spPr>
+        <p:style>
+          <a:lnRef idx="2">
+            <a:schemeClr val="accent1"/>
+          </a:lnRef>
+          <a:fillRef idx="0">
+            <a:schemeClr val="accent1"/>
+          </a:fillRef>
+          <a:effectRef idx="1">
+            <a:schemeClr val="accent1"/>
+          </a:effectRef>
+          <a:fontRef idx="minor">
+            <a:schemeClr val="tx1"/>
+          </a:fontRef>
+        </p:style>
+      </p:cxnSp>
+      <p:sp>
+        <p:nvSpPr>
+          <p:cNvPr id="13" name="Oval 12"/>
+          <p:cNvSpPr/>
+          <p:nvPr/>
+        </p:nvSpPr>
+        <p:spPr>
+          <a:xfrm>
+            <a:off x="7662671" y="4489704"/>
+            <a:ext cx="164592" cy="164592"/>
+          </a:xfrm>
+          <a:prstGeom prst="ellipse">
+            <a:avLst/>
+          </a:prstGeom>
+          <a:solidFill>
+            <a:srgbClr val="7C3AED"/>
+          </a:solidFill>
+          <a:ln>
+            <a:noFill/>
+          </a:ln>
+        </p:spPr>
+        <p:style>
+          <a:lnRef idx="1">
+            <a:schemeClr val="accent1"/>
+          </a:lnRef>
+          <a:fillRef idx="3">
+            <a:schemeClr val="accent1"/>
+          </a:fillRef>
+          <a:effectRef idx="2">
+            <a:schemeClr val="accent1"/>
+          </a:effectRef>
+          <a:fontRef idx="minor">
+            <a:schemeClr val="lt1"/>
+          </a:fontRef>
+        </p:style>
+        <p:txBody>
+          <a:bodyPr rtlCol="0" anchor="ctr"/>
+          <a:lstStyle/>
+          <a:p>
+            <a:pPr algn="ctr"/>
+          </a:p>
+        </p:txBody>
+      </p:sp>
+      <p:sp>
+        <p:nvSpPr>
+          <p:cNvPr id="14" name="Oval 13"/>
+          <p:cNvSpPr/>
+          <p:nvPr/>
+        </p:nvSpPr>
+        <p:spPr>
+          <a:xfrm>
+            <a:off x="6263640" y="3918204"/>
+            <a:ext cx="164592" cy="164592"/>
+          </a:xfrm>
+          <a:prstGeom prst="ellipse">
+            <a:avLst/>
+          </a:prstGeom>
+          <a:solidFill>
+            <a:srgbClr val="7C3AED"/>
+          </a:solidFill>
+          <a:ln>
+            <a:noFill/>
+          </a:ln>
+        </p:spPr>
+        <p:style>
+          <a:lnRef idx="1">
+            <a:schemeClr val="accent1"/>
+          </a:lnRef>
+          <a:fillRef idx="3">
+            <a:schemeClr val="accent1"/>
+          </a:fillRef>
+          <a:effectRef idx="2">
+            <a:schemeClr val="accent1"/>
+          </a:effectRef>
+          <a:fontRef idx="minor">
+            <a:schemeClr val="lt1"/>
+          </a:fontRef>
+        </p:style>
+        <p:txBody>
+          <a:bodyPr rtlCol="0" anchor="ctr"/>
+          <a:lstStyle/>
+          <a:p>
+            <a:pPr algn="ctr"/>
+          </a:p>
+        </p:txBody>
+      </p:sp>
+      <p:sp>
+        <p:nvSpPr>
+          <p:cNvPr id="15" name="Oval 14"/>
+          <p:cNvSpPr/>
+          <p:nvPr/>
+        </p:nvSpPr>
+        <p:spPr>
+          <a:xfrm>
+            <a:off x="4864608" y="3346704"/>
+            <a:ext cx="164592" cy="164592"/>
+          </a:xfrm>
+          <a:prstGeom prst="ellipse">
+            <a:avLst/>
+          </a:prstGeom>
+          <a:solidFill>
+            <a:srgbClr val="7C3AED"/>
+          </a:solidFill>
+          <a:ln>
+            <a:noFill/>
+          </a:ln>
+        </p:spPr>
+        <p:style>
+          <a:lnRef idx="1">
+            <a:schemeClr val="accent1"/>
+          </a:lnRef>
+          <a:fillRef idx="3">
+            <a:schemeClr val="accent1"/>
+          </a:fillRef>
+          <a:effectRef idx="2">
+            <a:schemeClr val="accent1"/>
+          </a:effectRef>
+          <a:fontRef idx="minor">
+            <a:schemeClr val="lt1"/>
+          </a:fontRef>
+        </p:style>
+        <p:txBody>
+          <a:bodyPr rtlCol="0" anchor="ctr"/>
+          <a:lstStyle/>
+          <a:p>
+            <a:pPr algn="ctr"/>
+          </a:p>
+        </p:txBody>
+      </p:sp>
+      <p:sp>
+        <p:nvSpPr>
+          <p:cNvPr id="16" name="Oval 15"/>
+          <p:cNvSpPr/>
+          <p:nvPr/>
+        </p:nvSpPr>
+        <p:spPr>
+          <a:xfrm>
+            <a:off x="3465575" y="2775204"/>
+            <a:ext cx="164592" cy="164592"/>
+          </a:xfrm>
+          <a:prstGeom prst="ellipse">
+            <a:avLst/>
+          </a:prstGeom>
+          <a:solidFill>
+            <a:srgbClr val="7C3AED"/>
+          </a:solidFill>
+          <a:ln>
+            <a:noFill/>
+          </a:ln>
+        </p:spPr>
+        <p:style>
+          <a:lnRef idx="1">
+            <a:schemeClr val="accent1"/>
+          </a:lnRef>
+          <a:fillRef idx="3">
+            <a:schemeClr val="accent1"/>
+          </a:fillRef>
+          <a:effectRef idx="2">
+            <a:schemeClr val="accent1"/>
+          </a:effectRef>
+          <a:fontRef idx="minor">
+            <a:schemeClr val="lt1"/>
+          </a:fontRef>
+        </p:style>
+        <p:txBody>
+          <a:bodyPr rtlCol="0" anchor="ctr"/>
+          <a:lstStyle/>
+          <a:p>
+            <a:pPr algn="ctr"/>
+          </a:p>
+        </p:txBody>
+      </p:sp>
+      <p:sp>
+        <p:nvSpPr>
+          <p:cNvPr id="17" name="Oval 16"/>
+          <p:cNvSpPr/>
+          <p:nvPr/>
+        </p:nvSpPr>
+        <p:spPr>
+          <a:xfrm>
+            <a:off x="10460736" y="4489704"/>
+            <a:ext cx="164592" cy="164592"/>
+          </a:xfrm>
+          <a:prstGeom prst="ellipse">
+            <a:avLst/>
+          </a:prstGeom>
+          <a:solidFill>
+            <a:srgbClr val="0891B2"/>
+          </a:solidFill>
+          <a:ln>
+            <a:noFill/>
+          </a:ln>
+        </p:spPr>
+        <p:style>
+          <a:lnRef idx="1">
+            <a:schemeClr val="accent1"/>
+          </a:lnRef>
+          <a:fillRef idx="3">
+            <a:schemeClr val="accent1"/>
+          </a:fillRef>
+          <a:effectRef idx="2">
+            <a:schemeClr val="accent1"/>
+          </a:effectRef>
+          <a:fontRef idx="minor">
+            <a:schemeClr val="lt1"/>
+          </a:fontRef>
+        </p:style>
+        <p:txBody>
+          <a:bodyPr rtlCol="0" anchor="ctr"/>
+          <a:lstStyle/>
+          <a:p>
+            <a:pPr algn="ctr"/>
+          </a:p>
+        </p:txBody>
+      </p:sp>
+      <p:sp>
+        <p:nvSpPr>
+          <p:cNvPr id="18" name="Oval 17"/>
+          <p:cNvSpPr/>
+          <p:nvPr/>
+        </p:nvSpPr>
+        <p:spPr>
+          <a:xfrm>
+            <a:off x="11859767" y="3918204"/>
+            <a:ext cx="164592" cy="164592"/>
+          </a:xfrm>
+          <a:prstGeom prst="ellipse">
+            <a:avLst/>
+          </a:prstGeom>
+          <a:solidFill>
+            <a:srgbClr val="0891B2"/>
+          </a:solidFill>
+          <a:ln>
+            <a:noFill/>
+          </a:ln>
+        </p:spPr>
+        <p:style>
+          <a:lnRef idx="1">
+            <a:schemeClr val="accent1"/>
+          </a:lnRef>
+          <a:fillRef idx="3">
+            <a:schemeClr val="accent1"/>
+          </a:fillRef>
+          <a:effectRef idx="2">
+            <a:schemeClr val="accent1"/>
+          </a:effectRef>
+          <a:fontRef idx="minor">
+            <a:schemeClr val="lt1"/>
+          </a:fontRef>
+        </p:style>
+        <p:txBody>
+          <a:bodyPr rtlCol="0" anchor="ctr"/>
+          <a:lstStyle/>
+          <a:p>
+            <a:pPr algn="ctr"/>
+          </a:p>
+        </p:txBody>
+      </p:sp>
+      <p:sp>
+        <p:nvSpPr>
+          <p:cNvPr id="19" name="Oval 18"/>
+          <p:cNvSpPr/>
+          <p:nvPr/>
+        </p:nvSpPr>
+        <p:spPr>
+          <a:xfrm>
+            <a:off x="13258800" y="3346704"/>
+            <a:ext cx="164592" cy="164592"/>
+          </a:xfrm>
+          <a:prstGeom prst="ellipse">
+            <a:avLst/>
+          </a:prstGeom>
+          <a:solidFill>
+            <a:srgbClr val="0891B2"/>
+          </a:solidFill>
+          <a:ln>
+            <a:noFill/>
+          </a:ln>
+        </p:spPr>
+        <p:style>
+          <a:lnRef idx="1">
+            <a:schemeClr val="accent1"/>
+          </a:lnRef>
+          <a:fillRef idx="3">
+            <a:schemeClr val="accent1"/>
+          </a:fillRef>
+          <a:effectRef idx="2">
+            <a:schemeClr val="accent1"/>
+          </a:effectRef>
+          <a:fontRef idx="minor">
+            <a:schemeClr val="lt1"/>
+          </a:fontRef>
+        </p:style>
+        <p:txBody>
+          <a:bodyPr rtlCol="0" anchor="ctr"/>
+          <a:lstStyle/>
+          <a:p>
+            <a:pPr algn="ctr"/>
+          </a:p>
+        </p:txBody>
+      </p:sp>
+      <p:sp>
+        <p:nvSpPr>
+          <p:cNvPr id="20" name="Oval 19"/>
+          <p:cNvSpPr/>
+          <p:nvPr/>
+        </p:nvSpPr>
+        <p:spPr>
+          <a:xfrm>
+            <a:off x="14657831" y="2775204"/>
+            <a:ext cx="164592" cy="164592"/>
+          </a:xfrm>
+          <a:prstGeom prst="ellipse">
+            <a:avLst/>
+          </a:prstGeom>
+          <a:solidFill>
+            <a:srgbClr val="0891B2"/>
+          </a:solidFill>
+          <a:ln>
+            <a:noFill/>
+          </a:ln>
+        </p:spPr>
+        <p:style>
+          <a:lnRef idx="1">
+            <a:schemeClr val="accent1"/>
+          </a:lnRef>
+          <a:fillRef idx="3">
+            <a:schemeClr val="accent1"/>
+          </a:fillRef>
+          <a:effectRef idx="2">
+            <a:schemeClr val="accent1"/>
+          </a:effectRef>
+          <a:fontRef idx="minor">
+            <a:schemeClr val="lt1"/>
+          </a:fontRef>
+        </p:style>
+        <p:txBody>
+          <a:bodyPr rtlCol="0" anchor="ctr"/>
+          <a:lstStyle/>
+          <a:p>
+            <a:pPr algn="ctr"/>
+          </a:p>
+        </p:txBody>
+      </p:sp>
+      <p:sp>
+        <p:nvSpPr>
+          <p:cNvPr id="21" name="Oval 20"/>
+          <p:cNvSpPr/>
+          <p:nvPr/>
+        </p:nvSpPr>
+        <p:spPr>
+          <a:xfrm>
+            <a:off x="7662671" y="5632704"/>
+            <a:ext cx="164592" cy="164592"/>
+          </a:xfrm>
+          <a:prstGeom prst="ellipse">
+            <a:avLst/>
+          </a:prstGeom>
+          <a:solidFill>
+            <a:srgbClr val="D97706"/>
+          </a:solidFill>
+          <a:ln>
+            <a:noFill/>
+          </a:ln>
+        </p:spPr>
+        <p:style>
+          <a:lnRef idx="1">
+            <a:schemeClr val="accent1"/>
+          </a:lnRef>
+          <a:fillRef idx="3">
+            <a:schemeClr val="accent1"/>
+          </a:fillRef>
+          <a:effectRef idx="2">
+            <a:schemeClr val="accent1"/>
+          </a:effectRef>
+          <a:fontRef idx="minor">
+            <a:schemeClr val="lt1"/>
+          </a:fontRef>
+        </p:style>
+        <p:txBody>
+          <a:bodyPr rtlCol="0" anchor="ctr"/>
+          <a:lstStyle/>
+          <a:p>
+            <a:pPr algn="ctr"/>
+          </a:p>
+        </p:txBody>
+      </p:sp>
+      <p:sp>
+        <p:nvSpPr>
+          <p:cNvPr id="22" name="Oval 21"/>
+          <p:cNvSpPr/>
+          <p:nvPr/>
+        </p:nvSpPr>
+        <p:spPr>
+          <a:xfrm>
+            <a:off x="6263640" y="6204204"/>
+            <a:ext cx="164592" cy="164592"/>
+          </a:xfrm>
+          <a:prstGeom prst="ellipse">
+            <a:avLst/>
+          </a:prstGeom>
+          <a:solidFill>
+            <a:srgbClr val="D97706"/>
+          </a:solidFill>
+          <a:ln>
+            <a:noFill/>
+          </a:ln>
+        </p:spPr>
+        <p:style>
+          <a:lnRef idx="1">
+            <a:schemeClr val="accent1"/>
+          </a:lnRef>
+          <a:fillRef idx="3">
+            <a:schemeClr val="accent1"/>
+          </a:fillRef>
+          <a:effectRef idx="2">
+            <a:schemeClr val="accent1"/>
+          </a:effectRef>
+          <a:fontRef idx="minor">
+            <a:schemeClr val="lt1"/>
+          </a:fontRef>
+        </p:style>
+        <p:txBody>
+          <a:bodyPr rtlCol="0" anchor="ctr"/>
+          <a:lstStyle/>
+          <a:p>
+            <a:pPr algn="ctr"/>
+          </a:p>
+        </p:txBody>
+      </p:sp>
+      <p:sp>
+        <p:nvSpPr>
+          <p:cNvPr id="23" name="Oval 22"/>
+          <p:cNvSpPr/>
+          <p:nvPr/>
+        </p:nvSpPr>
+        <p:spPr>
+          <a:xfrm>
+            <a:off x="4864608" y="6775704"/>
+            <a:ext cx="164592" cy="164592"/>
+          </a:xfrm>
+          <a:prstGeom prst="ellipse">
+            <a:avLst/>
+          </a:prstGeom>
+          <a:solidFill>
+            <a:srgbClr val="D97706"/>
+          </a:solidFill>
+          <a:ln>
+            <a:noFill/>
+          </a:ln>
+        </p:spPr>
+        <p:style>
+          <a:lnRef idx="1">
+            <a:schemeClr val="accent1"/>
+          </a:lnRef>
+          <a:fillRef idx="3">
+            <a:schemeClr val="accent1"/>
+          </a:fillRef>
+          <a:effectRef idx="2">
+            <a:schemeClr val="accent1"/>
+          </a:effectRef>
+          <a:fontRef idx="minor">
+            <a:schemeClr val="lt1"/>
+          </a:fontRef>
+        </p:style>
+        <p:txBody>
+          <a:bodyPr rtlCol="0" anchor="ctr"/>
+          <a:lstStyle/>
+          <a:p>
+            <a:pPr algn="ctr"/>
+          </a:p>
+        </p:txBody>
+      </p:sp>
+      <p:sp>
+        <p:nvSpPr>
+          <p:cNvPr id="24" name="Oval 23"/>
+          <p:cNvSpPr/>
+          <p:nvPr/>
+        </p:nvSpPr>
+        <p:spPr>
+          <a:xfrm>
+            <a:off x="3465575" y="7347204"/>
+            <a:ext cx="164592" cy="164592"/>
+          </a:xfrm>
+          <a:prstGeom prst="ellipse">
+            <a:avLst/>
+          </a:prstGeom>
+          <a:solidFill>
+            <a:srgbClr val="D97706"/>
+          </a:solidFill>
+          <a:ln>
+            <a:noFill/>
+          </a:ln>
+        </p:spPr>
+        <p:style>
+          <a:lnRef idx="1">
+            <a:schemeClr val="accent1"/>
+          </a:lnRef>
+          <a:fillRef idx="3">
+            <a:schemeClr val="accent1"/>
+          </a:fillRef>
+          <a:effectRef idx="2">
+            <a:schemeClr val="accent1"/>
+          </a:effectRef>
+          <a:fontRef idx="minor">
+            <a:schemeClr val="lt1"/>
+          </a:fontRef>
+        </p:style>
+        <p:txBody>
+          <a:bodyPr rtlCol="0" anchor="ctr"/>
+          <a:lstStyle/>
+          <a:p>
+            <a:pPr algn="ctr"/>
+          </a:p>
+        </p:txBody>
+      </p:sp>
+      <p:sp>
+        <p:nvSpPr>
+          <p:cNvPr id="25" name="Oval 24"/>
+          <p:cNvSpPr/>
+          <p:nvPr/>
+        </p:nvSpPr>
+        <p:spPr>
+          <a:xfrm>
+            <a:off x="10460736" y="5632704"/>
+            <a:ext cx="164592" cy="164592"/>
+          </a:xfrm>
+          <a:prstGeom prst="ellipse">
+            <a:avLst/>
+          </a:prstGeom>
+          <a:solidFill>
+            <a:srgbClr val="059669"/>
+          </a:solidFill>
+          <a:ln>
+            <a:noFill/>
+          </a:ln>
+        </p:spPr>
+        <p:style>
+          <a:lnRef idx="1">
+            <a:schemeClr val="accent1"/>
+          </a:lnRef>
+          <a:fillRef idx="3">
+            <a:schemeClr val="accent1"/>
+          </a:fillRef>
+          <a:effectRef idx="2">
+            <a:schemeClr val="accent1"/>
+          </a:effectRef>
+          <a:fontRef idx="minor">
+            <a:schemeClr val="lt1"/>
+          </a:fontRef>
+        </p:style>
+        <p:txBody>
+          <a:bodyPr rtlCol="0" anchor="ctr"/>
+          <a:lstStyle/>
+          <a:p>
+            <a:pPr algn="ctr"/>
+          </a:p>
+        </p:txBody>
+      </p:sp>
+      <p:sp>
+        <p:nvSpPr>
+          <p:cNvPr id="26" name="Oval 25"/>
+          <p:cNvSpPr/>
+          <p:nvPr/>
+        </p:nvSpPr>
+        <p:spPr>
+          <a:xfrm>
+            <a:off x="11859767" y="6204204"/>
+            <a:ext cx="164592" cy="164592"/>
+          </a:xfrm>
+          <a:prstGeom prst="ellipse">
+            <a:avLst/>
+          </a:prstGeom>
+          <a:solidFill>
+            <a:srgbClr val="059669"/>
+          </a:solidFill>
+          <a:ln>
+            <a:noFill/>
+          </a:ln>
+        </p:spPr>
+        <p:style>
+          <a:lnRef idx="1">
+            <a:schemeClr val="accent1"/>
+          </a:lnRef>
+          <a:fillRef idx="3">
+            <a:schemeClr val="accent1"/>
+          </a:fillRef>
+          <a:effectRef idx="2">
+            <a:schemeClr val="accent1"/>
+          </a:effectRef>
+          <a:fontRef idx="minor">
+            <a:schemeClr val="lt1"/>
+          </a:fontRef>
+        </p:style>
+        <p:txBody>
+          <a:bodyPr rtlCol="0" anchor="ctr"/>
+          <a:lstStyle/>
+          <a:p>
+            <a:pPr algn="ctr"/>
+          </a:p>
+        </p:txBody>
+      </p:sp>
+      <p:sp>
+        <p:nvSpPr>
+          <p:cNvPr id="27" name="Oval 26"/>
+          <p:cNvSpPr/>
+          <p:nvPr/>
+        </p:nvSpPr>
+        <p:spPr>
+          <a:xfrm>
+            <a:off x="13258800" y="6775704"/>
+            <a:ext cx="164592" cy="164592"/>
+          </a:xfrm>
+          <a:prstGeom prst="ellipse">
+            <a:avLst/>
+          </a:prstGeom>
+          <a:solidFill>
+            <a:srgbClr val="059669"/>
+          </a:solidFill>
+          <a:ln>
+            <a:noFill/>
+          </a:ln>
+        </p:spPr>
+        <p:style>
+          <a:lnRef idx="1">
+            <a:schemeClr val="accent1"/>
+          </a:lnRef>
+          <a:fillRef idx="3">
+            <a:schemeClr val="accent1"/>
+          </a:fillRef>
+          <a:effectRef idx="2">
+            <a:schemeClr val="accent1"/>
+          </a:effectRef>
+          <a:fontRef idx="minor">
+            <a:schemeClr val="lt1"/>
+          </a:fontRef>
+        </p:style>
+        <p:txBody>
+          <a:bodyPr rtlCol="0" anchor="ctr"/>
+          <a:lstStyle/>
+          <a:p>
+            <a:pPr algn="ctr"/>
+          </a:p>
+        </p:txBody>
+      </p:sp>
+      <p:sp>
+        <p:nvSpPr>
+          <p:cNvPr id="28" name="Oval 27"/>
+          <p:cNvSpPr/>
+          <p:nvPr/>
+        </p:nvSpPr>
+        <p:spPr>
+          <a:xfrm>
+            <a:off x="14657831" y="7347204"/>
+            <a:ext cx="164592" cy="164592"/>
+          </a:xfrm>
+          <a:prstGeom prst="ellipse">
+            <a:avLst/>
+          </a:prstGeom>
+          <a:solidFill>
+            <a:srgbClr val="059669"/>
+          </a:solidFill>
+          <a:ln>
+            <a:noFill/>
+          </a:ln>
+        </p:spPr>
+        <p:style>
+          <a:lnRef idx="1">
+            <a:schemeClr val="accent1"/>
+          </a:lnRef>
+          <a:fillRef idx="3">
+            <a:schemeClr val="accent1"/>
+          </a:fillRef>
+          <a:effectRef idx="2">
+            <a:schemeClr val="accent1"/>
+          </a:effectRef>
+          <a:fontRef idx="minor">
+            <a:schemeClr val="lt1"/>
+          </a:fontRef>
+        </p:style>
+        <p:txBody>
+          <a:bodyPr rtlCol="0" anchor="ctr"/>
+          <a:lstStyle/>
+          <a:p>
+            <a:pPr algn="ctr"/>
+          </a:p>
+        </p:txBody>
+      </p:sp>
+      <p:sp>
+        <p:nvSpPr>
+          <p:cNvPr id="29" name="Rounded Rectangle 28"/>
+          <p:cNvSpPr/>
+          <p:nvPr/>
+        </p:nvSpPr>
+        <p:spPr>
+          <a:xfrm>
+            <a:off x="274320" y="1097280"/>
+            <a:ext cx="3749039" cy="2834640"/>
+          </a:xfrm>
+          <a:prstGeom prst="roundRect">
+            <a:avLst/>
+          </a:prstGeom>
+          <a:noFill/>
+          <a:ln w="6350">
+            <a:solidFill>
+              <a:srgbClr val="7C3AED"/>
+            </a:solidFill>
+          </a:ln>
+        </p:spPr>
+        <p:style>
+          <a:lnRef idx="1">
+            <a:schemeClr val="accent1"/>
+          </a:lnRef>
+          <a:fillRef idx="3">
+            <a:schemeClr val="accent1"/>
+          </a:fillRef>
+          <a:effectRef idx="2">
+            <a:schemeClr val="accent1"/>
+          </a:effectRef>
+          <a:fontRef idx="minor">
+            <a:schemeClr val="lt1"/>
+          </a:fontRef>
+        </p:style>
+        <p:txBody>
+          <a:bodyPr rtlCol="0" anchor="ctr"/>
+          <a:lstStyle/>
+          <a:p>
+            <a:pPr algn="ctr"/>
+          </a:p>
+        </p:txBody>
+      </p:sp>
+      <p:sp>
+        <p:nvSpPr>
+          <p:cNvPr id="30" name="Rounded Rectangle 29"/>
+          <p:cNvSpPr/>
+          <p:nvPr/>
+        </p:nvSpPr>
+        <p:spPr>
+          <a:xfrm>
+            <a:off x="320040" y="1143000"/>
+            <a:ext cx="3657600" cy="2743200"/>
+          </a:xfrm>
+          <a:prstGeom prst="roundRect">
+            <a:avLst/>
+          </a:prstGeom>
+          <a:solidFill>
+            <a:srgbClr val="2D1254"/>
+          </a:solidFill>
+          <a:ln w="25400">
+            <a:solidFill>
+              <a:srgbClr val="9F67FF"/>
+            </a:solidFill>
+          </a:ln>
+        </p:spPr>
+        <p:style>
+          <a:lnRef idx="1">
+            <a:schemeClr val="accent1"/>
+          </a:lnRef>
+          <a:fillRef idx="3">
+            <a:schemeClr val="accent1"/>
+          </a:fillRef>
+          <a:effectRef idx="2">
+            <a:schemeClr val="accent1"/>
+          </a:effectRef>
+          <a:fontRef idx="minor">
+            <a:schemeClr val="lt1"/>
+          </a:fontRef>
+        </p:style>
+        <p:txBody>
+          <a:bodyPr rtlCol="0" anchor="ctr"/>
+          <a:lstStyle/>
+          <a:p>
+            <a:pPr algn="ctr"/>
+          </a:p>
+        </p:txBody>
+      </p:sp>
+      <p:sp>
+        <p:nvSpPr>
+          <p:cNvPr id="31" name="Rounded Rectangle 30"/>
+          <p:cNvSpPr/>
+          <p:nvPr/>
+        </p:nvSpPr>
+        <p:spPr>
+          <a:xfrm>
+            <a:off x="320040" y="1143000"/>
+            <a:ext cx="3657600" cy="640080"/>
+          </a:xfrm>
+          <a:prstGeom prst="roundRect">
+            <a:avLst/>
+          </a:prstGeom>
+          <a:solidFill>
+            <a:srgbClr val="7C3AED"/>
+          </a:solidFill>
+          <a:ln>
+            <a:noFill/>
+          </a:ln>
+        </p:spPr>
+        <p:style>
+          <a:lnRef idx="1">
+            <a:schemeClr val="accent1"/>
+          </a:lnRef>
+          <a:fillRef idx="3">
+            <a:schemeClr val="accent1"/>
+          </a:fillRef>
+          <a:effectRef idx="2">
+            <a:schemeClr val="accent1"/>
+          </a:effectRef>
+          <a:fontRef idx="minor">
+            <a:schemeClr val="lt1"/>
+          </a:fontRef>
+        </p:style>
+        <p:txBody>
+          <a:bodyPr rtlCol="0" anchor="ctr"/>
+          <a:lstStyle/>
+          <a:p>
+            <a:pPr algn="ctr"/>
+          </a:p>
+        </p:txBody>
+      </p:sp>
+      <p:sp>
+        <p:nvSpPr>
+          <p:cNvPr id="32" name="TextBox 31"/>
+          <p:cNvSpPr txBox="1"/>
+          <p:nvPr/>
+        </p:nvSpPr>
+        <p:spPr>
+          <a:xfrm>
+            <a:off x="429768" y="1197864"/>
+            <a:ext cx="3438144" cy="548640"/>
+          </a:xfrm>
+          <a:prstGeom prst="rect">
+            <a:avLst/>
+          </a:prstGeom>
+          <a:noFill/>
+        </p:spPr>
+        <p:txBody>
+          <a:bodyPr wrap="square">
+            <a:spAutoFit/>
+          </a:bodyPr>
+          <a:lstStyle/>
+          <a:p>
+            <a:pPr algn="ctr">
+              <a:spcBef>
+                <a:spcPts val="0"/>
+              </a:spcBef>
+              <a:spcAft>
+                <a:spcPts val="100"/>
+              </a:spcAft>
+            </a:pPr>
+            <a:r>
+              <a:rPr sz="1100" b="1">
+                <a:solidFill>
+                  <a:srgbClr val="FFFFFF"/>
+                </a:solidFill>
+                <a:latin typeface="Calibri"/>
+              </a:rPr>
+              <a:t>MD / DO  —  Physician Queue</a:t>
+            </a:r>
+          </a:p>
+        </p:txBody>
+      </p:sp>
+      <p:sp>
+        <p:nvSpPr>
+          <p:cNvPr id="33" name="TextBox 32"/>
+          <p:cNvSpPr txBox="1"/>
+          <p:nvPr/>
+        </p:nvSpPr>
+        <p:spPr>
+          <a:xfrm>
+            <a:off x="484632" y="1874519"/>
+            <a:ext cx="3364992" cy="438912"/>
+          </a:xfrm>
+          <a:prstGeom prst="rect">
+            <a:avLst/>
+          </a:prstGeom>
+          <a:noFill/>
+        </p:spPr>
+        <p:txBody>
+          <a:bodyPr wrap="square">
+            <a:spAutoFit/>
+          </a:bodyPr>
+          <a:lstStyle/>
+          <a:p>
+            <a:pPr algn="l">
+              <a:spcBef>
+                <a:spcPts val="0"/>
+              </a:spcBef>
+              <a:spcAft>
+                <a:spcPts val="100"/>
+              </a:spcAft>
+            </a:pPr>
+            <a:r>
+              <a:rPr sz="1000" b="0">
+                <a:solidFill>
+                  <a:srgbClr val="CBD5E1"/>
+                </a:solidFill>
+                <a:latin typeface="Calibri"/>
+              </a:rPr>
+              <a:t>▸  Async Rx Consults</a:t>
+            </a:r>
+          </a:p>
+        </p:txBody>
+      </p:sp>
+      <p:sp>
+        <p:nvSpPr>
+          <p:cNvPr id="34" name="TextBox 33"/>
+          <p:cNvSpPr txBox="1"/>
+          <p:nvPr/>
+        </p:nvSpPr>
+        <p:spPr>
+          <a:xfrm>
+            <a:off x="484632" y="2350008"/>
+            <a:ext cx="3364992" cy="438912"/>
+          </a:xfrm>
+          <a:prstGeom prst="rect">
+            <a:avLst/>
+          </a:prstGeom>
+          <a:noFill/>
+        </p:spPr>
+        <p:txBody>
+          <a:bodyPr wrap="square">
+            <a:spAutoFit/>
+          </a:bodyPr>
+          <a:lstStyle/>
+          <a:p>
+            <a:pPr algn="l">
+              <a:spcBef>
+                <a:spcPts val="0"/>
+              </a:spcBef>
+              <a:spcAft>
+                <a:spcPts val="100"/>
+              </a:spcAft>
+            </a:pPr>
+            <a:r>
+              <a:rPr sz="1000" b="0">
+                <a:solidFill>
+                  <a:srgbClr val="CBD5E1"/>
+                </a:solidFill>
+                <a:latin typeface="Calibri"/>
+              </a:rPr>
+              <a:t>▸  Video Consultations</a:t>
+            </a:r>
+          </a:p>
+        </p:txBody>
+      </p:sp>
+      <p:sp>
+        <p:nvSpPr>
+          <p:cNvPr id="35" name="TextBox 34"/>
+          <p:cNvSpPr txBox="1"/>
+          <p:nvPr/>
+        </p:nvSpPr>
+        <p:spPr>
+          <a:xfrm>
+            <a:off x="484632" y="2825496"/>
+            <a:ext cx="3364992" cy="438912"/>
+          </a:xfrm>
+          <a:prstGeom prst="rect">
+            <a:avLst/>
+          </a:prstGeom>
+          <a:noFill/>
+        </p:spPr>
+        <p:txBody>
+          <a:bodyPr wrap="square">
+            <a:spAutoFit/>
+          </a:bodyPr>
+          <a:lstStyle/>
+          <a:p>
+            <a:pPr algn="l">
+              <a:spcBef>
+                <a:spcPts val="0"/>
+              </a:spcBef>
+              <a:spcAft>
+                <a:spcPts val="100"/>
+              </a:spcAft>
+            </a:pPr>
+            <a:r>
+              <a:rPr sz="1000" b="0">
+                <a:solidFill>
+                  <a:srgbClr val="CBD5E1"/>
+                </a:solidFill>
+                <a:latin typeface="Calibri"/>
+              </a:rPr>
+              <a:t>▸  Lab Authorization</a:t>
+            </a:r>
+          </a:p>
+        </p:txBody>
+      </p:sp>
+      <p:sp>
+        <p:nvSpPr>
+          <p:cNvPr id="36" name="TextBox 35"/>
+          <p:cNvSpPr txBox="1"/>
+          <p:nvPr/>
+        </p:nvSpPr>
+        <p:spPr>
+          <a:xfrm>
+            <a:off x="484632" y="3300984"/>
+            <a:ext cx="3364992" cy="438912"/>
+          </a:xfrm>
+          <a:prstGeom prst="rect">
+            <a:avLst/>
+          </a:prstGeom>
+          <a:noFill/>
+        </p:spPr>
+        <p:txBody>
+          <a:bodyPr wrap="square">
+            <a:spAutoFit/>
+          </a:bodyPr>
+          <a:lstStyle/>
+          <a:p>
+            <a:pPr algn="l">
+              <a:spcBef>
+                <a:spcPts val="0"/>
+              </a:spcBef>
+              <a:spcAft>
+                <a:spcPts val="100"/>
+              </a:spcAft>
+            </a:pPr>
+            <a:r>
+              <a:rPr sz="1000" b="0">
+                <a:solidFill>
+                  <a:srgbClr val="CBD5E1"/>
+                </a:solidFill>
+                <a:latin typeface="Calibri"/>
+              </a:rPr>
+              <a:t>▸  Chart Closure</a:t>
+            </a:r>
+          </a:p>
+        </p:txBody>
+      </p:sp>
+      <p:sp>
+        <p:nvSpPr>
+          <p:cNvPr id="37" name="Rounded Rectangle 36"/>
+          <p:cNvSpPr/>
+          <p:nvPr/>
+        </p:nvSpPr>
+        <p:spPr>
+          <a:xfrm>
+            <a:off x="14264640" y="1097280"/>
+            <a:ext cx="3749039" cy="2834640"/>
+          </a:xfrm>
+          <a:prstGeom prst="roundRect">
+            <a:avLst/>
+          </a:prstGeom>
+          <a:noFill/>
+          <a:ln w="6350">
+            <a:solidFill>
+              <a:srgbClr val="0891B2"/>
+            </a:solidFill>
+          </a:ln>
+        </p:spPr>
+        <p:style>
+          <a:lnRef idx="1">
+            <a:schemeClr val="accent1"/>
+          </a:lnRef>
+          <a:fillRef idx="3">
+            <a:schemeClr val="accent1"/>
+          </a:fillRef>
+          <a:effectRef idx="2">
+            <a:schemeClr val="accent1"/>
+          </a:effectRef>
+          <a:fontRef idx="minor">
+            <a:schemeClr val="lt1"/>
+          </a:fontRef>
+        </p:style>
+        <p:txBody>
+          <a:bodyPr rtlCol="0" anchor="ctr"/>
+          <a:lstStyle/>
+          <a:p>
+            <a:pPr algn="ctr"/>
+          </a:p>
+        </p:txBody>
+      </p:sp>
+      <p:sp>
+        <p:nvSpPr>
+          <p:cNvPr id="38" name="Rounded Rectangle 37"/>
+          <p:cNvSpPr/>
+          <p:nvPr/>
+        </p:nvSpPr>
+        <p:spPr>
+          <a:xfrm>
+            <a:off x="14310360" y="1143000"/>
+            <a:ext cx="3657600" cy="2743200"/>
+          </a:xfrm>
+          <a:prstGeom prst="roundRect">
+            <a:avLst/>
+          </a:prstGeom>
+          <a:solidFill>
+            <a:srgbClr val="0B3042"/>
+          </a:solidFill>
+          <a:ln w="25400">
+            <a:solidFill>
+              <a:srgbClr val="22D3EE"/>
+            </a:solidFill>
+          </a:ln>
+        </p:spPr>
+        <p:style>
+          <a:lnRef idx="1">
+            <a:schemeClr val="accent1"/>
+          </a:lnRef>
+          <a:fillRef idx="3">
+            <a:schemeClr val="accent1"/>
+          </a:fillRef>
+          <a:effectRef idx="2">
+            <a:schemeClr val="accent1"/>
+          </a:effectRef>
+          <a:fontRef idx="minor">
+            <a:schemeClr val="lt1"/>
+          </a:fontRef>
+        </p:style>
+        <p:txBody>
+          <a:bodyPr rtlCol="0" anchor="ctr"/>
+          <a:lstStyle/>
+          <a:p>
+            <a:pPr algn="ctr"/>
+          </a:p>
+        </p:txBody>
+      </p:sp>
+      <p:sp>
+        <p:nvSpPr>
+          <p:cNvPr id="39" name="Rounded Rectangle 38"/>
+          <p:cNvSpPr/>
+          <p:nvPr/>
+        </p:nvSpPr>
+        <p:spPr>
+          <a:xfrm>
+            <a:off x="14310360" y="1143000"/>
+            <a:ext cx="3657600" cy="640080"/>
+          </a:xfrm>
+          <a:prstGeom prst="roundRect">
+            <a:avLst/>
+          </a:prstGeom>
+          <a:solidFill>
+            <a:srgbClr val="0891B2"/>
+          </a:solidFill>
+          <a:ln>
+            <a:noFill/>
+          </a:ln>
+        </p:spPr>
+        <p:style>
+          <a:lnRef idx="1">
+            <a:schemeClr val="accent1"/>
+          </a:lnRef>
+          <a:fillRef idx="3">
+            <a:schemeClr val="accent1"/>
+          </a:fillRef>
+          <a:effectRef idx="2">
+            <a:schemeClr val="accent1"/>
+          </a:effectRef>
+          <a:fontRef idx="minor">
+            <a:schemeClr val="lt1"/>
+          </a:fontRef>
+        </p:style>
+        <p:txBody>
+          <a:bodyPr rtlCol="0" anchor="ctr"/>
+          <a:lstStyle/>
+          <a:p>
+            <a:pPr algn="ctr"/>
+          </a:p>
+        </p:txBody>
+      </p:sp>
+      <p:sp>
+        <p:nvSpPr>
+          <p:cNvPr id="40" name="TextBox 39"/>
+          <p:cNvSpPr txBox="1"/>
+          <p:nvPr/>
+        </p:nvSpPr>
+        <p:spPr>
+          <a:xfrm>
+            <a:off x="14420088" y="1197864"/>
+            <a:ext cx="3438144" cy="548640"/>
+          </a:xfrm>
+          <a:prstGeom prst="rect">
+            <a:avLst/>
+          </a:prstGeom>
+          <a:noFill/>
+        </p:spPr>
+        <p:txBody>
+          <a:bodyPr wrap="square">
+            <a:spAutoFit/>
+          </a:bodyPr>
+          <a:lstStyle/>
+          <a:p>
+            <a:pPr algn="ctr">
+              <a:spcBef>
+                <a:spcPts val="0"/>
+              </a:spcBef>
+              <a:spcAft>
+                <a:spcPts val="100"/>
+              </a:spcAft>
+            </a:pPr>
+            <a:r>
+              <a:rPr sz="1100" b="1">
+                <a:solidFill>
+                  <a:srgbClr val="FFFFFF"/>
+                </a:solidFill>
+                <a:latin typeface="Calibri"/>
+              </a:rPr>
+              <a:t>RN  —  Nursing Queue</a:t>
+            </a:r>
+          </a:p>
+        </p:txBody>
+      </p:sp>
+      <p:sp>
+        <p:nvSpPr>
+          <p:cNvPr id="41" name="TextBox 40"/>
+          <p:cNvSpPr txBox="1"/>
+          <p:nvPr/>
+        </p:nvSpPr>
+        <p:spPr>
+          <a:xfrm>
+            <a:off x="14474952" y="1874519"/>
+            <a:ext cx="3364992" cy="438912"/>
+          </a:xfrm>
+          <a:prstGeom prst="rect">
+            <a:avLst/>
+          </a:prstGeom>
+          <a:noFill/>
+        </p:spPr>
+        <p:txBody>
+          <a:bodyPr wrap="square">
+            <a:spAutoFit/>
+          </a:bodyPr>
+          <a:lstStyle/>
+          <a:p>
+            <a:pPr algn="l">
+              <a:spcBef>
+                <a:spcPts val="0"/>
+              </a:spcBef>
+              <a:spcAft>
+                <a:spcPts val="100"/>
+              </a:spcAft>
+            </a:pPr>
+            <a:r>
+              <a:rPr sz="1000" b="0">
+                <a:solidFill>
+                  <a:srgbClr val="CBD5E1"/>
+                </a:solidFill>
+                <a:latin typeface="Calibri"/>
+              </a:rPr>
+              <a:t>▸  Critical Lab Triage</a:t>
+            </a:r>
+          </a:p>
+        </p:txBody>
+      </p:sp>
+      <p:sp>
+        <p:nvSpPr>
+          <p:cNvPr id="42" name="TextBox 41"/>
+          <p:cNvSpPr txBox="1"/>
+          <p:nvPr/>
+        </p:nvSpPr>
+        <p:spPr>
+          <a:xfrm>
+            <a:off x="14474952" y="2350008"/>
+            <a:ext cx="3364992" cy="438912"/>
+          </a:xfrm>
+          <a:prstGeom prst="rect">
+            <a:avLst/>
+          </a:prstGeom>
+          <a:noFill/>
+        </p:spPr>
+        <p:txBody>
+          <a:bodyPr wrap="square">
+            <a:spAutoFit/>
+          </a:bodyPr>
+          <a:lstStyle/>
+          <a:p>
+            <a:pPr algn="l">
+              <a:spcBef>
+                <a:spcPts val="0"/>
+              </a:spcBef>
+              <a:spcAft>
+                <a:spcPts val="100"/>
+              </a:spcAft>
+            </a:pPr>
+            <a:r>
+              <a:rPr sz="1000" b="0">
+                <a:solidFill>
+                  <a:srgbClr val="CBD5E1"/>
+                </a:solidFill>
+                <a:latin typeface="Calibri"/>
+              </a:rPr>
+              <a:t>▸  Titer Calls</a:t>
+            </a:r>
+          </a:p>
+        </p:txBody>
+      </p:sp>
+      <p:sp>
+        <p:nvSpPr>
+          <p:cNvPr id="43" name="TextBox 42"/>
+          <p:cNvSpPr txBox="1"/>
+          <p:nvPr/>
+        </p:nvSpPr>
+        <p:spPr>
+          <a:xfrm>
+            <a:off x="14474952" y="2825496"/>
+            <a:ext cx="3364992" cy="438912"/>
+          </a:xfrm>
+          <a:prstGeom prst="rect">
+            <a:avLst/>
+          </a:prstGeom>
+          <a:noFill/>
+        </p:spPr>
+        <p:txBody>
+          <a:bodyPr wrap="square">
+            <a:spAutoFit/>
+          </a:bodyPr>
+          <a:lstStyle/>
+          <a:p>
+            <a:pPr algn="l">
+              <a:spcBef>
+                <a:spcPts val="0"/>
+              </a:spcBef>
+              <a:spcAft>
+                <a:spcPts val="100"/>
+              </a:spcAft>
+            </a:pPr>
+            <a:r>
+              <a:rPr sz="1000" b="0">
+                <a:solidFill>
+                  <a:srgbClr val="CBD5E1"/>
+                </a:solidFill>
+                <a:latin typeface="Calibri"/>
+              </a:rPr>
+              <a:t>▸  SLA Escalations</a:t>
+            </a:r>
+          </a:p>
+        </p:txBody>
+      </p:sp>
+      <p:sp>
+        <p:nvSpPr>
+          <p:cNvPr id="44" name="TextBox 43"/>
+          <p:cNvSpPr txBox="1"/>
+          <p:nvPr/>
+        </p:nvSpPr>
+        <p:spPr>
+          <a:xfrm>
+            <a:off x="14474952" y="3300984"/>
+            <a:ext cx="3364992" cy="438912"/>
+          </a:xfrm>
+          <a:prstGeom prst="rect">
+            <a:avLst/>
+          </a:prstGeom>
+          <a:noFill/>
+        </p:spPr>
+        <p:txBody>
+          <a:bodyPr wrap="square">
+            <a:spAutoFit/>
+          </a:bodyPr>
+          <a:lstStyle/>
+          <a:p>
+            <a:pPr algn="l">
+              <a:spcBef>
+                <a:spcPts val="0"/>
+              </a:spcBef>
+              <a:spcAft>
+                <a:spcPts val="100"/>
+              </a:spcAft>
+            </a:pPr>
+            <a:r>
+              <a:rPr sz="1000" b="0">
+                <a:solidFill>
+                  <a:srgbClr val="CBD5E1"/>
+                </a:solidFill>
+                <a:latin typeface="Calibri"/>
+              </a:rPr>
+              <a:t>▸  On-Call Coverage</a:t>
+            </a:r>
+          </a:p>
+        </p:txBody>
+      </p:sp>
+      <p:sp>
+        <p:nvSpPr>
+          <p:cNvPr id="45" name="Rounded Rectangle 44"/>
+          <p:cNvSpPr/>
+          <p:nvPr/>
+        </p:nvSpPr>
+        <p:spPr>
+          <a:xfrm>
+            <a:off x="274320" y="6812280"/>
+            <a:ext cx="3749039" cy="2743200"/>
+          </a:xfrm>
+          <a:prstGeom prst="roundRect">
+            <a:avLst/>
+          </a:prstGeom>
+          <a:noFill/>
+          <a:ln w="6350">
+            <a:solidFill>
+              <a:srgbClr val="D97706"/>
+            </a:solidFill>
+          </a:ln>
+        </p:spPr>
+        <p:style>
+          <a:lnRef idx="1">
+            <a:schemeClr val="accent1"/>
+          </a:lnRef>
+          <a:fillRef idx="3">
+            <a:schemeClr val="accent1"/>
+          </a:fillRef>
+          <a:effectRef idx="2">
+            <a:schemeClr val="accent1"/>
+          </a:effectRef>
+          <a:fontRef idx="minor">
+            <a:schemeClr val="lt1"/>
+          </a:fontRef>
+        </p:style>
+        <p:txBody>
+          <a:bodyPr rtlCol="0" anchor="ctr"/>
+          <a:lstStyle/>
+          <a:p>
+            <a:pPr algn="ctr"/>
+          </a:p>
+        </p:txBody>
+      </p:sp>
+      <p:sp>
+        <p:nvSpPr>
+          <p:cNvPr id="46" name="Rounded Rectangle 45"/>
+          <p:cNvSpPr/>
+          <p:nvPr/>
+        </p:nvSpPr>
+        <p:spPr>
+          <a:xfrm>
+            <a:off x="320040" y="6858000"/>
+            <a:ext cx="3657600" cy="2651760"/>
+          </a:xfrm>
+          <a:prstGeom prst="roundRect">
+            <a:avLst/>
+          </a:prstGeom>
+          <a:solidFill>
+            <a:srgbClr val="3D2000"/>
+          </a:solidFill>
+          <a:ln w="25400">
+            <a:solidFill>
+              <a:srgbClr val="FCD34D"/>
+            </a:solidFill>
+          </a:ln>
+        </p:spPr>
+        <p:style>
+          <a:lnRef idx="1">
+            <a:schemeClr val="accent1"/>
+          </a:lnRef>
+          <a:fillRef idx="3">
+            <a:schemeClr val="accent1"/>
+          </a:fillRef>
+          <a:effectRef idx="2">
+            <a:schemeClr val="accent1"/>
+          </a:effectRef>
+          <a:fontRef idx="minor">
+            <a:schemeClr val="lt1"/>
+          </a:fontRef>
+        </p:style>
+        <p:txBody>
+          <a:bodyPr rtlCol="0" anchor="ctr"/>
+          <a:lstStyle/>
+          <a:p>
+            <a:pPr algn="ctr"/>
+          </a:p>
+        </p:txBody>
+      </p:sp>
+      <p:sp>
+        <p:nvSpPr>
+          <p:cNvPr id="47" name="Rounded Rectangle 46"/>
+          <p:cNvSpPr/>
+          <p:nvPr/>
+        </p:nvSpPr>
+        <p:spPr>
+          <a:xfrm>
+            <a:off x="320040" y="6858000"/>
+            <a:ext cx="3657600" cy="640080"/>
+          </a:xfrm>
+          <a:prstGeom prst="roundRect">
+            <a:avLst/>
+          </a:prstGeom>
+          <a:solidFill>
+            <a:srgbClr val="D97706"/>
+          </a:solidFill>
+          <a:ln>
+            <a:noFill/>
+          </a:ln>
+        </p:spPr>
+        <p:style>
+          <a:lnRef idx="1">
+            <a:schemeClr val="accent1"/>
+          </a:lnRef>
+          <a:fillRef idx="3">
+            <a:schemeClr val="accent1"/>
+          </a:fillRef>
+          <a:effectRef idx="2">
+            <a:schemeClr val="accent1"/>
+          </a:effectRef>
+          <a:fontRef idx="minor">
+            <a:schemeClr val="lt1"/>
+          </a:fontRef>
+        </p:style>
+        <p:txBody>
+          <a:bodyPr rtlCol="0" anchor="ctr"/>
+          <a:lstStyle/>
+          <a:p>
+            <a:pPr algn="ctr"/>
+          </a:p>
+        </p:txBody>
+      </p:sp>
+      <p:sp>
+        <p:nvSpPr>
+          <p:cNvPr id="48" name="TextBox 47"/>
+          <p:cNvSpPr txBox="1"/>
+          <p:nvPr/>
+        </p:nvSpPr>
+        <p:spPr>
+          <a:xfrm>
+            <a:off x="429768" y="6912864"/>
+            <a:ext cx="3438144" cy="548640"/>
+          </a:xfrm>
+          <a:prstGeom prst="rect">
+            <a:avLst/>
+          </a:prstGeom>
+          <a:noFill/>
+        </p:spPr>
+        <p:txBody>
+          <a:bodyPr wrap="square">
+            <a:spAutoFit/>
+          </a:bodyPr>
+          <a:lstStyle/>
+          <a:p>
+            <a:pPr algn="ctr">
+              <a:spcBef>
+                <a:spcPts val="0"/>
+              </a:spcBef>
+              <a:spcAft>
+                <a:spcPts val="100"/>
+              </a:spcAft>
+            </a:pPr>
+            <a:r>
+              <a:rPr sz="1100" b="1">
+                <a:solidFill>
+                  <a:srgbClr val="FFFFFF"/>
+                </a:solidFill>
+                <a:latin typeface="Calibri"/>
+              </a:rPr>
+              <a:t>MA  —  Medical Assistant Queue</a:t>
+            </a:r>
+          </a:p>
+        </p:txBody>
+      </p:sp>
+      <p:sp>
+        <p:nvSpPr>
+          <p:cNvPr id="49" name="TextBox 48"/>
+          <p:cNvSpPr txBox="1"/>
+          <p:nvPr/>
+        </p:nvSpPr>
+        <p:spPr>
+          <a:xfrm>
+            <a:off x="484632" y="7589520"/>
+            <a:ext cx="3364992" cy="438912"/>
+          </a:xfrm>
+          <a:prstGeom prst="rect">
+            <a:avLst/>
+          </a:prstGeom>
+          <a:noFill/>
+        </p:spPr>
+        <p:txBody>
+          <a:bodyPr wrap="square">
+            <a:spAutoFit/>
+          </a:bodyPr>
+          <a:lstStyle/>
+          <a:p>
+            <a:pPr algn="l">
+              <a:spcBef>
+                <a:spcPts val="0"/>
+              </a:spcBef>
+              <a:spcAft>
+                <a:spcPts val="100"/>
+              </a:spcAft>
+            </a:pPr>
+            <a:r>
+              <a:rPr sz="1000" b="0">
+                <a:solidFill>
+                  <a:srgbClr val="CBD5E1"/>
+                </a:solidFill>
+                <a:latin typeface="Calibri"/>
+              </a:rPr>
+              <a:t>▸  Intake Processing</a:t>
+            </a:r>
+          </a:p>
+        </p:txBody>
+      </p:sp>
+      <p:sp>
+        <p:nvSpPr>
+          <p:cNvPr id="50" name="TextBox 49"/>
+          <p:cNvSpPr txBox="1"/>
+          <p:nvPr/>
+        </p:nvSpPr>
+        <p:spPr>
+          <a:xfrm>
+            <a:off x="484632" y="8065008"/>
+            <a:ext cx="3364992" cy="438912"/>
+          </a:xfrm>
+          <a:prstGeom prst="rect">
+            <a:avLst/>
+          </a:prstGeom>
+          <a:noFill/>
+        </p:spPr>
+        <p:txBody>
+          <a:bodyPr wrap="square">
+            <a:spAutoFit/>
+          </a:bodyPr>
+          <a:lstStyle/>
+          <a:p>
+            <a:pPr algn="l">
+              <a:spcBef>
+                <a:spcPts val="0"/>
+              </a:spcBef>
+              <a:spcAft>
+                <a:spcPts val="100"/>
+              </a:spcAft>
+            </a:pPr>
+            <a:r>
+              <a:rPr sz="1000" b="0">
+                <a:solidFill>
+                  <a:srgbClr val="CBD5E1"/>
+                </a:solidFill>
+                <a:latin typeface="Calibri"/>
+              </a:rPr>
+              <a:t>▸  Prior Authorizations</a:t>
+            </a:r>
+          </a:p>
+        </p:txBody>
+      </p:sp>
+      <p:sp>
+        <p:nvSpPr>
+          <p:cNvPr id="51" name="TextBox 50"/>
+          <p:cNvSpPr txBox="1"/>
+          <p:nvPr/>
+        </p:nvSpPr>
+        <p:spPr>
+          <a:xfrm>
+            <a:off x="484632" y="8540496"/>
+            <a:ext cx="3364992" cy="438912"/>
+          </a:xfrm>
+          <a:prstGeom prst="rect">
+            <a:avLst/>
+          </a:prstGeom>
+          <a:noFill/>
+        </p:spPr>
+        <p:txBody>
+          <a:bodyPr wrap="square">
+            <a:spAutoFit/>
+          </a:bodyPr>
+          <a:lstStyle/>
+          <a:p>
+            <a:pPr algn="l">
+              <a:spcBef>
+                <a:spcPts val="0"/>
+              </a:spcBef>
+              <a:spcAft>
+                <a:spcPts val="100"/>
+              </a:spcAft>
+            </a:pPr>
+            <a:r>
+              <a:rPr sz="1000" b="0">
+                <a:solidFill>
+                  <a:srgbClr val="CBD5E1"/>
+                </a:solidFill>
+                <a:latin typeface="Calibri"/>
+              </a:rPr>
+              <a:t>▸  Patient Reminders</a:t>
+            </a:r>
+          </a:p>
+        </p:txBody>
+      </p:sp>
+      <p:sp>
+        <p:nvSpPr>
+          <p:cNvPr id="52" name="TextBox 51"/>
+          <p:cNvSpPr txBox="1"/>
+          <p:nvPr/>
+        </p:nvSpPr>
+        <p:spPr>
+          <a:xfrm>
+            <a:off x="484632" y="9015984"/>
+            <a:ext cx="3364992" cy="438912"/>
+          </a:xfrm>
+          <a:prstGeom prst="rect">
+            <a:avLst/>
+          </a:prstGeom>
+          <a:noFill/>
+        </p:spPr>
+        <p:txBody>
+          <a:bodyPr wrap="square">
+            <a:spAutoFit/>
+          </a:bodyPr>
+          <a:lstStyle/>
+          <a:p>
+            <a:pPr algn="l">
+              <a:spcBef>
+                <a:spcPts val="0"/>
+              </a:spcBef>
+              <a:spcAft>
+                <a:spcPts val="100"/>
+              </a:spcAft>
+            </a:pPr>
+            <a:r>
+              <a:rPr sz="1000" b="0">
+                <a:solidFill>
+                  <a:srgbClr val="CBD5E1"/>
+                </a:solidFill>
+                <a:latin typeface="Calibri"/>
+              </a:rPr>
+              <a:t>▸  Lab Scheduling</a:t>
+            </a:r>
+          </a:p>
+        </p:txBody>
+      </p:sp>
+      <p:sp>
+        <p:nvSpPr>
+          <p:cNvPr id="53" name="Rounded Rectangle 52"/>
+          <p:cNvSpPr/>
+          <p:nvPr/>
+        </p:nvSpPr>
+        <p:spPr>
+          <a:xfrm>
+            <a:off x="14264640" y="6812280"/>
+            <a:ext cx="3749039" cy="2743200"/>
+          </a:xfrm>
+          <a:prstGeom prst="roundRect">
+            <a:avLst/>
+          </a:prstGeom>
+          <a:noFill/>
+          <a:ln w="6350">
+            <a:solidFill>
+              <a:srgbClr val="059669"/>
+            </a:solidFill>
+          </a:ln>
+        </p:spPr>
+        <p:style>
+          <a:lnRef idx="1">
+            <a:schemeClr val="accent1"/>
+          </a:lnRef>
+          <a:fillRef idx="3">
+            <a:schemeClr val="accent1"/>
+          </a:fillRef>
+          <a:effectRef idx="2">
+            <a:schemeClr val="accent1"/>
+          </a:effectRef>
+          <a:fontRef idx="minor">
+            <a:schemeClr val="lt1"/>
+          </a:fontRef>
+        </p:style>
+        <p:txBody>
+          <a:bodyPr rtlCol="0" anchor="ctr"/>
+          <a:lstStyle/>
+          <a:p>
+            <a:pPr algn="ctr"/>
+          </a:p>
+        </p:txBody>
+      </p:sp>
+      <p:sp>
+        <p:nvSpPr>
+          <p:cNvPr id="54" name="Rounded Rectangle 53"/>
+          <p:cNvSpPr/>
+          <p:nvPr/>
+        </p:nvSpPr>
+        <p:spPr>
+          <a:xfrm>
+            <a:off x="14310360" y="6858000"/>
+            <a:ext cx="3657600" cy="2651760"/>
+          </a:xfrm>
+          <a:prstGeom prst="roundRect">
+            <a:avLst/>
+          </a:prstGeom>
+          <a:solidFill>
+            <a:srgbClr val="012A1A"/>
+          </a:solidFill>
+          <a:ln w="25400">
+            <a:solidFill>
+              <a:srgbClr val="34D399"/>
+            </a:solidFill>
+          </a:ln>
+        </p:spPr>
+        <p:style>
+          <a:lnRef idx="1">
+            <a:schemeClr val="accent1"/>
+          </a:lnRef>
+          <a:fillRef idx="3">
+            <a:schemeClr val="accent1"/>
+          </a:fillRef>
+          <a:effectRef idx="2">
+            <a:schemeClr val="accent1"/>
+          </a:effectRef>
+          <a:fontRef idx="minor">
+            <a:schemeClr val="lt1"/>
+          </a:fontRef>
+        </p:style>
+        <p:txBody>
+          <a:bodyPr rtlCol="0" anchor="ctr"/>
+          <a:lstStyle/>
+          <a:p>
+            <a:pPr algn="ctr"/>
+          </a:p>
+        </p:txBody>
+      </p:sp>
+      <p:sp>
+        <p:nvSpPr>
+          <p:cNvPr id="55" name="Rounded Rectangle 54"/>
+          <p:cNvSpPr/>
+          <p:nvPr/>
+        </p:nvSpPr>
+        <p:spPr>
+          <a:xfrm>
+            <a:off x="14310360" y="6858000"/>
+            <a:ext cx="3657600" cy="640080"/>
+          </a:xfrm>
+          <a:prstGeom prst="roundRect">
+            <a:avLst/>
+          </a:prstGeom>
+          <a:solidFill>
+            <a:srgbClr val="059669"/>
+          </a:solidFill>
+          <a:ln>
+            <a:noFill/>
+          </a:ln>
+        </p:spPr>
+        <p:style>
+          <a:lnRef idx="1">
+            <a:schemeClr val="accent1"/>
+          </a:lnRef>
+          <a:fillRef idx="3">
+            <a:schemeClr val="accent1"/>
+          </a:fillRef>
+          <a:effectRef idx="2">
+            <a:schemeClr val="accent1"/>
+          </a:effectRef>
+          <a:fontRef idx="minor">
+            <a:schemeClr val="lt1"/>
+          </a:fontRef>
+        </p:style>
+        <p:txBody>
+          <a:bodyPr rtlCol="0" anchor="ctr"/>
+          <a:lstStyle/>
+          <a:p>
+            <a:pPr algn="ctr"/>
+          </a:p>
+        </p:txBody>
+      </p:sp>
+      <p:sp>
+        <p:nvSpPr>
+          <p:cNvPr id="56" name="TextBox 55"/>
+          <p:cNvSpPr txBox="1"/>
+          <p:nvPr/>
+        </p:nvSpPr>
+        <p:spPr>
+          <a:xfrm>
+            <a:off x="14420088" y="6912864"/>
+            <a:ext cx="3438144" cy="548640"/>
+          </a:xfrm>
+          <a:prstGeom prst="rect">
+            <a:avLst/>
+          </a:prstGeom>
+          <a:noFill/>
+        </p:spPr>
+        <p:txBody>
+          <a:bodyPr wrap="square">
+            <a:spAutoFit/>
+          </a:bodyPr>
+          <a:lstStyle/>
+          <a:p>
+            <a:pPr algn="ctr">
+              <a:spcBef>
+                <a:spcPts val="0"/>
+              </a:spcBef>
+              <a:spcAft>
+                <a:spcPts val="100"/>
+              </a:spcAft>
+            </a:pPr>
+            <a:r>
+              <a:rPr sz="1100" b="1">
+                <a:solidFill>
+                  <a:srgbClr val="FFFFFF"/>
+                </a:solidFill>
+                <a:latin typeface="Calibri"/>
+              </a:rPr>
+              <a:t>CT  —  Care Team Queue</a:t>
+            </a:r>
+          </a:p>
+        </p:txBody>
+      </p:sp>
+      <p:sp>
+        <p:nvSpPr>
+          <p:cNvPr id="57" name="TextBox 56"/>
+          <p:cNvSpPr txBox="1"/>
+          <p:nvPr/>
+        </p:nvSpPr>
+        <p:spPr>
+          <a:xfrm>
+            <a:off x="14474952" y="7589520"/>
+            <a:ext cx="3364992" cy="438912"/>
+          </a:xfrm>
+          <a:prstGeom prst="rect">
+            <a:avLst/>
+          </a:prstGeom>
+          <a:noFill/>
+        </p:spPr>
+        <p:txBody>
+          <a:bodyPr wrap="square">
+            <a:spAutoFit/>
+          </a:bodyPr>
+          <a:lstStyle/>
+          <a:p>
+            <a:pPr algn="l">
+              <a:spcBef>
+                <a:spcPts val="0"/>
+              </a:spcBef>
+              <a:spcAft>
+                <a:spcPts val="100"/>
+              </a:spcAft>
+            </a:pPr>
+            <a:r>
+              <a:rPr sz="1000" b="0">
+                <a:solidFill>
+                  <a:srgbClr val="CBD5E1"/>
+                </a:solidFill>
+                <a:latin typeface="Calibri"/>
+              </a:rPr>
+              <a:t>▸  Abnormal Outreach</a:t>
+            </a:r>
+          </a:p>
+        </p:txBody>
+      </p:sp>
+      <p:sp>
+        <p:nvSpPr>
+          <p:cNvPr id="58" name="TextBox 57"/>
+          <p:cNvSpPr txBox="1"/>
+          <p:nvPr/>
+        </p:nvSpPr>
+        <p:spPr>
+          <a:xfrm>
+            <a:off x="14474952" y="8065008"/>
+            <a:ext cx="3364992" cy="438912"/>
+          </a:xfrm>
+          <a:prstGeom prst="rect">
+            <a:avLst/>
+          </a:prstGeom>
+          <a:noFill/>
+        </p:spPr>
+        <p:txBody>
+          <a:bodyPr wrap="square">
+            <a:spAutoFit/>
+          </a:bodyPr>
+          <a:lstStyle/>
+          <a:p>
+            <a:pPr algn="l">
+              <a:spcBef>
+                <a:spcPts val="0"/>
+              </a:spcBef>
+              <a:spcAft>
+                <a:spcPts val="100"/>
+              </a:spcAft>
+            </a:pPr>
+            <a:r>
+              <a:rPr sz="1000" b="0">
+                <a:solidFill>
+                  <a:srgbClr val="CBD5E1"/>
+                </a:solidFill>
+                <a:latin typeface="Calibri"/>
+              </a:rPr>
+              <a:t>▸  Reassignment Tasks</a:t>
+            </a:r>
+          </a:p>
+        </p:txBody>
+      </p:sp>
+      <p:sp>
+        <p:nvSpPr>
+          <p:cNvPr id="59" name="TextBox 58"/>
+          <p:cNvSpPr txBox="1"/>
+          <p:nvPr/>
+        </p:nvSpPr>
+        <p:spPr>
+          <a:xfrm>
+            <a:off x="14474952" y="8540496"/>
+            <a:ext cx="3364992" cy="438912"/>
+          </a:xfrm>
+          <a:prstGeom prst="rect">
+            <a:avLst/>
+          </a:prstGeom>
+          <a:noFill/>
+        </p:spPr>
+        <p:txBody>
+          <a:bodyPr wrap="square">
+            <a:spAutoFit/>
+          </a:bodyPr>
+          <a:lstStyle/>
+          <a:p>
+            <a:pPr algn="l">
+              <a:spcBef>
+                <a:spcPts val="0"/>
+              </a:spcBef>
+              <a:spcAft>
+                <a:spcPts val="100"/>
+              </a:spcAft>
+            </a:pPr>
+            <a:r>
+              <a:rPr sz="1000" b="0">
+                <a:solidFill>
+                  <a:srgbClr val="CBD5E1"/>
+                </a:solidFill>
+                <a:latin typeface="Calibri"/>
+              </a:rPr>
+              <a:t>▸  Complex Cases</a:t>
+            </a:r>
+          </a:p>
+        </p:txBody>
+      </p:sp>
+      <p:sp>
+        <p:nvSpPr>
+          <p:cNvPr id="60" name="TextBox 59"/>
+          <p:cNvSpPr txBox="1"/>
+          <p:nvPr/>
+        </p:nvSpPr>
+        <p:spPr>
+          <a:xfrm>
+            <a:off x="14474952" y="9015984"/>
+            <a:ext cx="3364992" cy="438912"/>
+          </a:xfrm>
+          <a:prstGeom prst="rect">
+            <a:avLst/>
+          </a:prstGeom>
+          <a:noFill/>
+        </p:spPr>
+        <p:txBody>
+          <a:bodyPr wrap="square">
+            <a:spAutoFit/>
+          </a:bodyPr>
+          <a:lstStyle/>
+          <a:p>
+            <a:pPr algn="l">
+              <a:spcBef>
+                <a:spcPts val="0"/>
+              </a:spcBef>
+              <a:spcAft>
+                <a:spcPts val="100"/>
+              </a:spcAft>
+            </a:pPr>
+            <a:r>
+              <a:rPr sz="1000" b="0">
+                <a:solidFill>
+                  <a:srgbClr val="CBD5E1"/>
+                </a:solidFill>
+                <a:latin typeface="Calibri"/>
+              </a:rPr>
+              <a:t>▸  PSR Call Queue</a:t>
+            </a:r>
+          </a:p>
+        </p:txBody>
+      </p:sp>
+      <p:sp>
+        <p:nvSpPr>
+          <p:cNvPr id="61" name="Oval 60"/>
+          <p:cNvSpPr/>
+          <p:nvPr/>
+        </p:nvSpPr>
+        <p:spPr>
+          <a:xfrm>
+            <a:off x="7406640" y="3954780"/>
+            <a:ext cx="3474720" cy="2377440"/>
+          </a:xfrm>
+          <a:prstGeom prst="ellipse">
+            <a:avLst/>
+          </a:prstGeom>
+          <a:noFill/>
+          <a:ln w="7620">
+            <a:solidFill>
+              <a:srgbClr val="4C1D95"/>
+            </a:solidFill>
+          </a:ln>
+        </p:spPr>
+        <p:style>
+          <a:lnRef idx="1">
+            <a:schemeClr val="accent1"/>
+          </a:lnRef>
+          <a:fillRef idx="3">
+            <a:schemeClr val="accent1"/>
+          </a:fillRef>
+          <a:effectRef idx="2">
+            <a:schemeClr val="accent1"/>
+          </a:effectRef>
+          <a:fontRef idx="minor">
+            <a:schemeClr val="lt1"/>
+          </a:fontRef>
+        </p:style>
+        <p:txBody>
+          <a:bodyPr rtlCol="0" anchor="ctr"/>
+          <a:lstStyle/>
+          <a:p>
+            <a:pPr algn="ctr"/>
+          </a:p>
+        </p:txBody>
+      </p:sp>
+      <p:sp>
+        <p:nvSpPr>
+          <p:cNvPr id="62" name="Oval 61"/>
+          <p:cNvSpPr/>
+          <p:nvPr/>
+        </p:nvSpPr>
+        <p:spPr>
+          <a:xfrm>
+            <a:off x="7772400" y="4229100"/>
+            <a:ext cx="2743200" cy="1828800"/>
+          </a:xfrm>
+          <a:prstGeom prst="ellipse">
+            <a:avLst/>
+          </a:prstGeom>
+          <a:noFill/>
+          <a:ln w="12700">
+            <a:solidFill>
+              <a:srgbClr val="6D28D9"/>
+            </a:solidFill>
+          </a:ln>
+        </p:spPr>
+        <p:style>
+          <a:lnRef idx="1">
+            <a:schemeClr val="accent1"/>
+          </a:lnRef>
+          <a:fillRef idx="3">
+            <a:schemeClr val="accent1"/>
+          </a:fillRef>
+          <a:effectRef idx="2">
+            <a:schemeClr val="accent1"/>
+          </a:effectRef>
+          <a:fontRef idx="minor">
+            <a:schemeClr val="lt1"/>
+          </a:fontRef>
+        </p:style>
+        <p:txBody>
+          <a:bodyPr rtlCol="0" anchor="ctr"/>
+          <a:lstStyle/>
+          <a:p>
+            <a:pPr algn="ctr"/>
+          </a:p>
+        </p:txBody>
+      </p:sp>
+      <p:sp>
+        <p:nvSpPr>
+          <p:cNvPr id="63" name="Oval 62"/>
+          <p:cNvSpPr/>
+          <p:nvPr/>
+        </p:nvSpPr>
+        <p:spPr>
+          <a:xfrm>
+            <a:off x="7955279" y="4320540"/>
+            <a:ext cx="2377440" cy="1645920"/>
+          </a:xfrm>
+          <a:prstGeom prst="ellipse">
+            <a:avLst/>
+          </a:prstGeom>
+          <a:solidFill>
+            <a:srgbClr val="1E0B3E"/>
+          </a:solidFill>
+          <a:ln w="31750">
+            <a:solidFill>
+              <a:srgbClr val="7C3AED"/>
+            </a:solidFill>
+          </a:ln>
+        </p:spPr>
+        <p:style>
+          <a:lnRef idx="1">
+            <a:schemeClr val="accent1"/>
+          </a:lnRef>
+          <a:fillRef idx="3">
+            <a:schemeClr val="accent1"/>
+          </a:fillRef>
+          <a:effectRef idx="2">
+            <a:schemeClr val="accent1"/>
+          </a:effectRef>
+          <a:fontRef idx="minor">
+            <a:schemeClr val="lt1"/>
+          </a:fontRef>
+        </p:style>
+        <p:txBody>
+          <a:bodyPr rtlCol="0" anchor="ctr"/>
+          <a:lstStyle/>
+          <a:p>
+            <a:pPr algn="ctr"/>
+          </a:p>
+        </p:txBody>
+      </p:sp>
+      <p:sp>
+        <p:nvSpPr>
+          <p:cNvPr id="64" name="TextBox 63"/>
+          <p:cNvSpPr txBox="1"/>
+          <p:nvPr/>
+        </p:nvSpPr>
+        <p:spPr>
+          <a:xfrm>
+            <a:off x="8046720" y="4393692"/>
+            <a:ext cx="2194560" cy="1499616"/>
+          </a:xfrm>
+          <a:prstGeom prst="rect">
+            <a:avLst/>
+          </a:prstGeom>
+          <a:noFill/>
+        </p:spPr>
+        <p:txBody>
+          <a:bodyPr wrap="square">
+            <a:spAutoFit/>
+          </a:bodyPr>
+          <a:lstStyle/>
+          <a:p>
+            <a:pPr algn="ctr">
+              <a:spcBef>
+                <a:spcPts val="0"/>
+              </a:spcBef>
+              <a:spcAft>
+                <a:spcPts val="100"/>
+              </a:spcAft>
+            </a:pPr>
+            <a:r>
+              <a:rPr sz="1500" b="0">
+                <a:solidFill>
+                  <a:srgbClr val="F9A8D4"/>
+                </a:solidFill>
+                <a:latin typeface="Calibri"/>
+              </a:rPr>
+              <a:t>⚡</a:t>
+            </a:r>
+          </a:p>
+          <a:p>
+            <a:pPr algn="ctr">
+              <a:spcBef>
+                <a:spcPts val="0"/>
+              </a:spcBef>
+              <a:spcAft>
+                <a:spcPts val="100"/>
+              </a:spcAft>
+            </a:pPr>
+            <a:r>
+              <a:rPr sz="950" b="1">
+                <a:solidFill>
+                  <a:srgbClr val="C4B5FD"/>
+                </a:solidFill>
+                <a:latin typeface="Calibri"/>
+              </a:rPr>
+              <a:t>PLATFORM</a:t>
+            </a:r>
+          </a:p>
+          <a:p>
+            <a:pPr algn="ctr">
+              <a:spcBef>
+                <a:spcPts val="0"/>
+              </a:spcBef>
+              <a:spcAft>
+                <a:spcPts val="100"/>
+              </a:spcAft>
+            </a:pPr>
+            <a:r>
+              <a:rPr sz="950" b="1">
+                <a:solidFill>
+                  <a:srgbClr val="C4B5FD"/>
+                </a:solidFill>
+                <a:latin typeface="Calibri"/>
+              </a:rPr>
+              <a:t>INTELLIGENCE</a:t>
+            </a:r>
+          </a:p>
+          <a:p>
+            <a:pPr algn="ctr">
+              <a:spcBef>
+                <a:spcPts val="0"/>
+              </a:spcBef>
+              <a:spcAft>
+                <a:spcPts val="100"/>
+              </a:spcAft>
+            </a:pPr>
+            <a:r>
+              <a:rPr sz="950" b="1">
+                <a:solidFill>
+                  <a:srgbClr val="C4B5FD"/>
+                </a:solidFill>
+                <a:latin typeface="Calibri"/>
+              </a:rPr>
+              <a:t>HUB</a:t>
+            </a:r>
+          </a:p>
+        </p:txBody>
+      </p:sp>
+      <p:sp>
+        <p:nvSpPr>
+          <p:cNvPr id="65" name="Rounded Rectangle 64"/>
+          <p:cNvSpPr/>
+          <p:nvPr/>
+        </p:nvSpPr>
+        <p:spPr>
+          <a:xfrm>
+            <a:off x="5532120" y="3419856"/>
+            <a:ext cx="1920240" cy="292608"/>
+          </a:xfrm>
+          <a:prstGeom prst="roundRect">
+            <a:avLst/>
+          </a:prstGeom>
+          <a:solidFill>
+            <a:srgbClr val="0F1D30"/>
+          </a:solidFill>
+          <a:ln w="9525">
+            <a:solidFill>
+              <a:srgbClr val="9F67FF"/>
+            </a:solidFill>
+          </a:ln>
+        </p:spPr>
+        <p:style>
+          <a:lnRef idx="1">
+            <a:schemeClr val="accent1"/>
+          </a:lnRef>
+          <a:fillRef idx="3">
+            <a:schemeClr val="accent1"/>
+          </a:fillRef>
+          <a:effectRef idx="2">
+            <a:schemeClr val="accent1"/>
+          </a:effectRef>
+          <a:fontRef idx="minor">
+            <a:schemeClr val="lt1"/>
+          </a:fontRef>
+        </p:style>
+        <p:txBody>
+          <a:bodyPr rtlCol="0" anchor="ctr"/>
+          <a:lstStyle/>
+          <a:p>
+            <a:pPr algn="ctr"/>
+          </a:p>
+        </p:txBody>
+      </p:sp>
+      <p:sp>
+        <p:nvSpPr>
+          <p:cNvPr id="66" name="TextBox 65"/>
+          <p:cNvSpPr txBox="1"/>
+          <p:nvPr/>
+        </p:nvSpPr>
+        <p:spPr>
+          <a:xfrm>
+            <a:off x="5577840" y="3438144"/>
+            <a:ext cx="1828800" cy="310896"/>
+          </a:xfrm>
+          <a:prstGeom prst="rect">
+            <a:avLst/>
+          </a:prstGeom>
+          <a:noFill/>
+        </p:spPr>
+        <p:txBody>
+          <a:bodyPr wrap="square">
+            <a:spAutoFit/>
+          </a:bodyPr>
+          <a:lstStyle/>
+          <a:p>
+            <a:pPr algn="ctr">
+              <a:spcBef>
+                <a:spcPts val="0"/>
+              </a:spcBef>
+              <a:spcAft>
+                <a:spcPts val="100"/>
+              </a:spcAft>
+            </a:pPr>
+            <a:r>
+              <a:rPr sz="800" b="0">
+                <a:solidFill>
+                  <a:srgbClr val="9F67FF"/>
+                </a:solidFill>
+                <a:latin typeface="Calibri"/>
+              </a:rPr>
+              <a:t>Rx · Async · Video</a:t>
+            </a:r>
+          </a:p>
+        </p:txBody>
+      </p:sp>
+      <p:sp>
+        <p:nvSpPr>
+          <p:cNvPr id="67" name="Rounded Rectangle 66"/>
+          <p:cNvSpPr/>
+          <p:nvPr/>
+        </p:nvSpPr>
+        <p:spPr>
+          <a:xfrm>
+            <a:off x="11612880" y="3419856"/>
+            <a:ext cx="1920240" cy="292608"/>
+          </a:xfrm>
+          <a:prstGeom prst="roundRect">
+            <a:avLst/>
+          </a:prstGeom>
+          <a:solidFill>
+            <a:srgbClr val="0F1D30"/>
+          </a:solidFill>
+          <a:ln w="9525">
+            <a:solidFill>
+              <a:srgbClr val="22D3EE"/>
+            </a:solidFill>
+          </a:ln>
+        </p:spPr>
+        <p:style>
+          <a:lnRef idx="1">
+            <a:schemeClr val="accent1"/>
+          </a:lnRef>
+          <a:fillRef idx="3">
+            <a:schemeClr val="accent1"/>
+          </a:fillRef>
+          <a:effectRef idx="2">
+            <a:schemeClr val="accent1"/>
+          </a:effectRef>
+          <a:fontRef idx="minor">
+            <a:schemeClr val="lt1"/>
+          </a:fontRef>
+        </p:style>
+        <p:txBody>
+          <a:bodyPr rtlCol="0" anchor="ctr"/>
+          <a:lstStyle/>
+          <a:p>
+            <a:pPr algn="ctr"/>
+          </a:p>
+        </p:txBody>
+      </p:sp>
+      <p:sp>
+        <p:nvSpPr>
+          <p:cNvPr id="68" name="TextBox 67"/>
+          <p:cNvSpPr txBox="1"/>
+          <p:nvPr/>
+        </p:nvSpPr>
+        <p:spPr>
+          <a:xfrm>
+            <a:off x="11658600" y="3438144"/>
+            <a:ext cx="1828800" cy="310896"/>
+          </a:xfrm>
+          <a:prstGeom prst="rect">
+            <a:avLst/>
+          </a:prstGeom>
+          <a:noFill/>
+        </p:spPr>
+        <p:txBody>
+          <a:bodyPr wrap="square">
+            <a:spAutoFit/>
+          </a:bodyPr>
+          <a:lstStyle/>
+          <a:p>
+            <a:pPr algn="ctr">
+              <a:spcBef>
+                <a:spcPts val="0"/>
+              </a:spcBef>
+              <a:spcAft>
+                <a:spcPts val="100"/>
+              </a:spcAft>
+            </a:pPr>
+            <a:r>
+              <a:rPr sz="800" b="0">
+                <a:solidFill>
+                  <a:srgbClr val="22D3EE"/>
+                </a:solidFill>
+                <a:latin typeface="Calibri"/>
+              </a:rPr>
+              <a:t>Labs · Titers · SLA</a:t>
+            </a:r>
+          </a:p>
+        </p:txBody>
+      </p:sp>
+      <p:sp>
+        <p:nvSpPr>
+          <p:cNvPr id="69" name="Rounded Rectangle 68"/>
+          <p:cNvSpPr/>
+          <p:nvPr/>
+        </p:nvSpPr>
+        <p:spPr>
+          <a:xfrm>
+            <a:off x="5532120" y="6547104"/>
+            <a:ext cx="1920240" cy="292608"/>
+          </a:xfrm>
+          <a:prstGeom prst="roundRect">
+            <a:avLst/>
+          </a:prstGeom>
+          <a:solidFill>
+            <a:srgbClr val="0F1D30"/>
+          </a:solidFill>
+          <a:ln w="9525">
+            <a:solidFill>
+              <a:srgbClr val="FCD34D"/>
+            </a:solidFill>
+          </a:ln>
+        </p:spPr>
+        <p:style>
+          <a:lnRef idx="1">
+            <a:schemeClr val="accent1"/>
+          </a:lnRef>
+          <a:fillRef idx="3">
+            <a:schemeClr val="accent1"/>
+          </a:fillRef>
+          <a:effectRef idx="2">
+            <a:schemeClr val="accent1"/>
+          </a:effectRef>
+          <a:fontRef idx="minor">
+            <a:schemeClr val="lt1"/>
+          </a:fontRef>
+        </p:style>
+        <p:txBody>
+          <a:bodyPr rtlCol="0" anchor="ctr"/>
+          <a:lstStyle/>
+          <a:p>
+            <a:pPr algn="ctr"/>
+          </a:p>
+        </p:txBody>
+      </p:sp>
+      <p:sp>
+        <p:nvSpPr>
+          <p:cNvPr id="70" name="TextBox 69"/>
+          <p:cNvSpPr txBox="1"/>
+          <p:nvPr/>
+        </p:nvSpPr>
+        <p:spPr>
+          <a:xfrm>
+            <a:off x="5577840" y="6565392"/>
+            <a:ext cx="1828800" cy="310896"/>
+          </a:xfrm>
+          <a:prstGeom prst="rect">
+            <a:avLst/>
+          </a:prstGeom>
+          <a:noFill/>
+        </p:spPr>
+        <p:txBody>
+          <a:bodyPr wrap="square">
+            <a:spAutoFit/>
+          </a:bodyPr>
+          <a:lstStyle/>
+          <a:p>
+            <a:pPr algn="ctr">
+              <a:spcBef>
+                <a:spcPts val="0"/>
+              </a:spcBef>
+              <a:spcAft>
+                <a:spcPts val="100"/>
+              </a:spcAft>
+            </a:pPr>
+            <a:r>
+              <a:rPr sz="800" b="0">
+                <a:solidFill>
+                  <a:srgbClr val="FCD34D"/>
+                </a:solidFill>
+                <a:latin typeface="Calibri"/>
+              </a:rPr>
+              <a:t>Intake · PA · Reminders</a:t>
+            </a:r>
+          </a:p>
+        </p:txBody>
+      </p:sp>
+      <p:sp>
+        <p:nvSpPr>
+          <p:cNvPr id="71" name="Rounded Rectangle 70"/>
+          <p:cNvSpPr/>
+          <p:nvPr/>
+        </p:nvSpPr>
+        <p:spPr>
+          <a:xfrm>
+            <a:off x="11612880" y="6547104"/>
+            <a:ext cx="1920240" cy="292608"/>
+          </a:xfrm>
+          <a:prstGeom prst="roundRect">
+            <a:avLst/>
+          </a:prstGeom>
+          <a:solidFill>
+            <a:srgbClr val="0F1D30"/>
+          </a:solidFill>
+          <a:ln w="9525">
+            <a:solidFill>
+              <a:srgbClr val="34D399"/>
+            </a:solidFill>
+          </a:ln>
+        </p:spPr>
+        <p:style>
+          <a:lnRef idx="1">
+            <a:schemeClr val="accent1"/>
+          </a:lnRef>
+          <a:fillRef idx="3">
+            <a:schemeClr val="accent1"/>
+          </a:fillRef>
+          <a:effectRef idx="2">
+            <a:schemeClr val="accent1"/>
+          </a:effectRef>
+          <a:fontRef idx="minor">
+            <a:schemeClr val="lt1"/>
+          </a:fontRef>
+        </p:style>
+        <p:txBody>
+          <a:bodyPr rtlCol="0" anchor="ctr"/>
+          <a:lstStyle/>
+          <a:p>
+            <a:pPr algn="ctr"/>
+          </a:p>
+        </p:txBody>
+      </p:sp>
+      <p:sp>
+        <p:nvSpPr>
+          <p:cNvPr id="72" name="TextBox 71"/>
+          <p:cNvSpPr txBox="1"/>
+          <p:nvPr/>
+        </p:nvSpPr>
+        <p:spPr>
+          <a:xfrm>
+            <a:off x="11658600" y="6565392"/>
+            <a:ext cx="1828800" cy="310896"/>
+          </a:xfrm>
+          <a:prstGeom prst="rect">
+            <a:avLst/>
+          </a:prstGeom>
+          <a:noFill/>
+        </p:spPr>
+        <p:txBody>
+          <a:bodyPr wrap="square">
+            <a:spAutoFit/>
+          </a:bodyPr>
+          <a:lstStyle/>
+          <a:p>
+            <a:pPr algn="ctr">
+              <a:spcBef>
+                <a:spcPts val="0"/>
+              </a:spcBef>
+              <a:spcAft>
+                <a:spcPts val="100"/>
+              </a:spcAft>
+            </a:pPr>
+            <a:r>
+              <a:rPr sz="800" b="0">
+                <a:solidFill>
+                  <a:srgbClr val="34D399"/>
+                </a:solidFill>
+                <a:latin typeface="Calibri"/>
+              </a:rPr>
+              <a:t>Outreach · Cases · PSR</a:t>
+            </a:r>
+          </a:p>
+        </p:txBody>
+      </p:sp>
+      <p:sp>
+        <p:nvSpPr>
+          <p:cNvPr id="73" name="Rectangle 72"/>
+          <p:cNvSpPr/>
+          <p:nvPr/>
+        </p:nvSpPr>
+        <p:spPr>
+          <a:xfrm>
+            <a:off x="0" y="0"/>
+            <a:ext cx="18288000" cy="960120"/>
+          </a:xfrm>
+          <a:prstGeom prst="rect">
+            <a:avLst/>
+          </a:prstGeom>
+          <a:solidFill>
+            <a:srgbClr val="150A2E"/>
+          </a:solidFill>
+          <a:ln>
+            <a:noFill/>
+          </a:ln>
+        </p:spPr>
+        <p:style>
+          <a:lnRef idx="1">
+            <a:schemeClr val="accent1"/>
+          </a:lnRef>
+          <a:fillRef idx="3">
+            <a:schemeClr val="accent1"/>
+          </a:fillRef>
+          <a:effectRef idx="2">
+            <a:schemeClr val="accent1"/>
+          </a:effectRef>
+          <a:fontRef idx="minor">
+            <a:schemeClr val="lt1"/>
+          </a:fontRef>
+        </p:style>
+        <p:txBody>
+          <a:bodyPr rtlCol="0" anchor="ctr"/>
+          <a:lstStyle/>
+          <a:p>
+            <a:pPr algn="ctr"/>
+          </a:p>
+        </p:txBody>
+      </p:sp>
+      <p:sp>
+        <p:nvSpPr>
+          <p:cNvPr id="74" name="TextBox 73"/>
+          <p:cNvSpPr txBox="1"/>
+          <p:nvPr/>
+        </p:nvSpPr>
+        <p:spPr>
+          <a:xfrm>
+            <a:off x="320040" y="73152"/>
+            <a:ext cx="17647920" cy="475488"/>
+          </a:xfrm>
+          <a:prstGeom prst="rect">
+            <a:avLst/>
+          </a:prstGeom>
+          <a:noFill/>
+        </p:spPr>
+        <p:txBody>
+          <a:bodyPr wrap="square">
+            <a:spAutoFit/>
+          </a:bodyPr>
+          <a:lstStyle/>
+          <a:p>
+            <a:pPr algn="l">
+              <a:spcBef>
+                <a:spcPts val="0"/>
+              </a:spcBef>
+              <a:spcAft>
+                <a:spcPts val="100"/>
+              </a:spcAft>
+            </a:pPr>
+            <a:r>
+              <a:rPr sz="2000" b="1">
+                <a:solidFill>
+                  <a:srgbClr val="FFFFFF"/>
+                </a:solidFill>
+                <a:latin typeface="Calibri"/>
+              </a:rPr>
+              <a:t>Everlywell Telehealth Platform — Air Traffic Control</a:t>
+            </a:r>
+          </a:p>
+        </p:txBody>
+      </p:sp>
+      <p:sp>
+        <p:nvSpPr>
+          <p:cNvPr id="75" name="TextBox 74"/>
+          <p:cNvSpPr txBox="1"/>
+          <p:nvPr/>
+        </p:nvSpPr>
+        <p:spPr>
+          <a:xfrm>
+            <a:off x="320040" y="548640"/>
+            <a:ext cx="17647920" cy="365760"/>
+          </a:xfrm>
+          <a:prstGeom prst="rect">
+            <a:avLst/>
+          </a:prstGeom>
+          <a:noFill/>
+        </p:spPr>
+        <p:txBody>
+          <a:bodyPr wrap="square">
+            <a:spAutoFit/>
+          </a:bodyPr>
+          <a:lstStyle/>
+          <a:p>
+            <a:pPr algn="l">
+              <a:spcBef>
+                <a:spcPts val="0"/>
+              </a:spcBef>
+              <a:spcAft>
+                <a:spcPts val="100"/>
+              </a:spcAft>
+            </a:pPr>
+            <a:r>
+              <a:rPr sz="1000" b="0">
+                <a:solidFill>
+                  <a:srgbClr val="C4B5FD"/>
+                </a:solidFill>
+                <a:latin typeface="Calibri"/>
+              </a:rPr>
+              <a:t>The platform routes every patient consult to the right provider queue automatically — eliminating manual triage, Slack coordination, and missed handoffs</a:t>
+            </a:r>
+          </a:p>
+        </p:txBody>
+      </p:sp>
+      <p:sp>
+        <p:nvSpPr>
+          <p:cNvPr id="76" name="Rectangle 75"/>
+          <p:cNvSpPr/>
+          <p:nvPr/>
+        </p:nvSpPr>
+        <p:spPr>
+          <a:xfrm>
+            <a:off x="0" y="9692640"/>
+            <a:ext cx="18288000" cy="594360"/>
+          </a:xfrm>
+          <a:prstGeom prst="rect">
+            <a:avLst/>
+          </a:prstGeom>
+          <a:solidFill>
+            <a:srgbClr val="150A2E"/>
+          </a:solidFill>
+          <a:ln>
+            <a:noFill/>
+          </a:ln>
+        </p:spPr>
+        <p:style>
+          <a:lnRef idx="1">
+            <a:schemeClr val="accent1"/>
+          </a:lnRef>
+          <a:fillRef idx="3">
+            <a:schemeClr val="accent1"/>
+          </a:fillRef>
+          <a:effectRef idx="2">
+            <a:schemeClr val="accent1"/>
+          </a:effectRef>
+          <a:fontRef idx="minor">
+            <a:schemeClr val="lt1"/>
+          </a:fontRef>
+        </p:style>
+        <p:txBody>
+          <a:bodyPr rtlCol="0" anchor="ctr"/>
+          <a:lstStyle/>
+          <a:p>
+            <a:pPr algn="ctr"/>
+          </a:p>
+        </p:txBody>
+      </p:sp>
+      <p:sp>
+        <p:nvSpPr>
+          <p:cNvPr id="77" name="TextBox 76"/>
+          <p:cNvSpPr txBox="1"/>
+          <p:nvPr/>
+        </p:nvSpPr>
+        <p:spPr>
+          <a:xfrm>
+            <a:off x="457200" y="9802367"/>
+            <a:ext cx="17373600" cy="457200"/>
+          </a:xfrm>
+          <a:prstGeom prst="rect">
+            <a:avLst/>
+          </a:prstGeom>
+          <a:noFill/>
+        </p:spPr>
+        <p:txBody>
+          <a:bodyPr wrap="square">
+            <a:spAutoFit/>
+          </a:bodyPr>
+          <a:lstStyle/>
+          <a:p>
+            <a:pPr algn="ctr">
+              <a:spcBef>
+                <a:spcPts val="0"/>
+              </a:spcBef>
+              <a:spcAft>
+                <a:spcPts val="100"/>
+              </a:spcAft>
+            </a:pPr>
+            <a:r>
+              <a:rPr sz="1100" b="1">
+                <a:solidFill>
+                  <a:srgbClr val="C4B5FD"/>
+                </a:solidFill>
+                <a:latin typeface="Calibri"/>
+              </a:rPr>
+              <a:t>4 Role Queues   ·   Automatic Routing by Consult Type   ·   SLA-Tracked   ·   Zero Manual Triage   ·   Full Audit Trail   ·   Real-Time</a:t>
             </a:r>
           </a:p>
         </p:txBody>

</xml_diff>